<commit_message>
docs(theory): add rendered proposal slides
</commit_message>
<xml_diff>
--- a/.codex-build/ytterbium-clock-proposal/candidate.pptx
+++ b/.codex-build/ytterbium-clock-proposal/candidate.pptx
@@ -2,24 +2,26 @@
 <file path=ppt/presentation.xml><?xml version="1.0" encoding="utf-8"?>
 <p:presentation xmlns:p="http://schemas.openxmlformats.org/presentationml/2006/main">
   <p:sldMasterIdLst>
-    <p:sldMasterId xmlns:r="http://schemas.openxmlformats.org/officeDocument/2006/relationships" id="2147483648" r:id="Rc21fa20b98d140cc"/>
+    <p:sldMasterId xmlns:r="http://schemas.openxmlformats.org/officeDocument/2006/relationships" id="2147483648" r:id="R73fb64b0db9d4e62"/>
   </p:sldMasterIdLst>
   <p:notesMasterIdLst>
-    <p:notesMasterId xmlns:r="http://schemas.openxmlformats.org/officeDocument/2006/relationships" r:id="R3b78ace9a8324b97"/>
+    <p:notesMasterId xmlns:r="http://schemas.openxmlformats.org/officeDocument/2006/relationships" r:id="R84cfc08b067b4d53"/>
   </p:notesMasterIdLst>
   <p:sldIdLst>
-    <p:sldId xmlns:r="http://schemas.openxmlformats.org/officeDocument/2006/relationships" id="256" r:id="R5d04d55c6d5241af"/>
-    <p:sldId xmlns:r="http://schemas.openxmlformats.org/officeDocument/2006/relationships" id="257" r:id="R6d54debd6b3c4415"/>
-    <p:sldId xmlns:r="http://schemas.openxmlformats.org/officeDocument/2006/relationships" id="258" r:id="R8f2dba0b134f41c3"/>
-    <p:sldId xmlns:r="http://schemas.openxmlformats.org/officeDocument/2006/relationships" id="259" r:id="R411af30970794aff"/>
-    <p:sldId xmlns:r="http://schemas.openxmlformats.org/officeDocument/2006/relationships" id="260" r:id="R2da5418fc51f4766"/>
-    <p:sldId xmlns:r="http://schemas.openxmlformats.org/officeDocument/2006/relationships" id="261" r:id="R597610f072c94f1c"/>
-    <p:sldId xmlns:r="http://schemas.openxmlformats.org/officeDocument/2006/relationships" id="262" r:id="Rb07006d822c645b0"/>
-    <p:sldId xmlns:r="http://schemas.openxmlformats.org/officeDocument/2006/relationships" id="263" r:id="R16ec81fc9993480a"/>
-    <p:sldId xmlns:r="http://schemas.openxmlformats.org/officeDocument/2006/relationships" id="264" r:id="Rb3da9a1fae334bec"/>
-    <p:sldId xmlns:r="http://schemas.openxmlformats.org/officeDocument/2006/relationships" id="265" r:id="R37c5a7c2fb7b41fb"/>
-    <p:sldId xmlns:r="http://schemas.openxmlformats.org/officeDocument/2006/relationships" id="266" r:id="R81765450e2674f2f"/>
-    <p:sldId xmlns:r="http://schemas.openxmlformats.org/officeDocument/2006/relationships" id="267" r:id="R7db6c14f39d042f7"/>
+    <p:sldId xmlns:r="http://schemas.openxmlformats.org/officeDocument/2006/relationships" id="256" r:id="R07c6eba1515443d1"/>
+    <p:sldId xmlns:r="http://schemas.openxmlformats.org/officeDocument/2006/relationships" id="257" r:id="R51e69329807d4685"/>
+    <p:sldId xmlns:r="http://schemas.openxmlformats.org/officeDocument/2006/relationships" id="258" r:id="R0ee0b61db1004cc4"/>
+    <p:sldId xmlns:r="http://schemas.openxmlformats.org/officeDocument/2006/relationships" id="259" r:id="R6045021c47774b4d"/>
+    <p:sldId xmlns:r="http://schemas.openxmlformats.org/officeDocument/2006/relationships" id="260" r:id="R0ca6e79dbb404a37"/>
+    <p:sldId xmlns:r="http://schemas.openxmlformats.org/officeDocument/2006/relationships" id="261" r:id="R797944ae9acb4fa1"/>
+    <p:sldId xmlns:r="http://schemas.openxmlformats.org/officeDocument/2006/relationships" id="262" r:id="Rac8a50ea8e464c83"/>
+    <p:sldId xmlns:r="http://schemas.openxmlformats.org/officeDocument/2006/relationships" id="263" r:id="R766d4c3de8f74c42"/>
+    <p:sldId xmlns:r="http://schemas.openxmlformats.org/officeDocument/2006/relationships" id="264" r:id="R387c74bcf8ba4efc"/>
+    <p:sldId xmlns:r="http://schemas.openxmlformats.org/officeDocument/2006/relationships" id="265" r:id="R2270b18b76f1414f"/>
+    <p:sldId xmlns:r="http://schemas.openxmlformats.org/officeDocument/2006/relationships" id="266" r:id="R6955489c168c4146"/>
+    <p:sldId xmlns:r="http://schemas.openxmlformats.org/officeDocument/2006/relationships" id="267" r:id="Rd694d89f07164b0f"/>
+    <p:sldId xmlns:r="http://schemas.openxmlformats.org/officeDocument/2006/relationships" id="268" r:id="R5b514ba33a7a4914"/>
+    <p:sldId xmlns:r="http://schemas.openxmlformats.org/officeDocument/2006/relationships" id="269" r:id="Rba16e5e0b59b48d8"/>
   </p:sldIdLst>
   <p:sldSz cx="12192000" cy="6858000"/>
   <p:notesSz cx="6858000" cy="9144000"/>
@@ -533,12 +535,12 @@
           </a:p>
           <a:p xmlns:a="http://schemas.openxmlformats.org/drawingml/2006/main">
             <a:r>
-              <a:t>https://www.nature.com/articles/s41567-018-0197-6</a:t>
-            </a:r>
-          </a:p>
-          <a:p xmlns:a="http://schemas.openxmlformats.org/drawingml/2006/main">
-            <a:r>
-              <a:t>Each κ± divides corrected measured gravitational phase by a prediction from that encoding's measured spectroscopic gap and an independently measured potential difference.</a:t>
+              <a:t>Ideal parity model checked by shared/theory/ytterbium-clock-proposal-calculation.ts. This algebraic model check is not validation of the complete measurement hardware.</a:t>
+            </a:r>
+          </a:p>
+          <a:p xmlns:a="http://schemas.openxmlformats.org/drawingml/2006/main">
+            <a:r>
+              <a:t>Exact example: {"plus":0.2602872306978985,"minus":0.7397127693021015}</a:t>
             </a:r>
           </a:p>
         </p:txBody>
@@ -608,17 +610,22 @@
           <a:lstStyle xmlns:a="http://schemas.openxmlformats.org/drawingml/2006/main"/>
           <a:p xmlns:a="http://schemas.openxmlformats.org/drawingml/2006/main">
             <a:r>
+              <a:t>https://chatgpt.com/share/6ab672dc-e820-83ea-a2a5-26643690422a</a:t>
+            </a:r>
+          </a:p>
+          <a:p xmlns:a="http://schemas.openxmlformats.org/drawingml/2006/main">
+            <a:r>
+              <a:t>https://www.bipm.org/documents/20126/288516347/171Yb_518THz_2025/73007ecc-49f5-4d1d-d8ee-6793a4748598</a:t>
+            </a:r>
+          </a:p>
+          <a:p xmlns:a="http://schemas.openxmlformats.org/drawingml/2006/main">
+            <a:r>
               <a:t>https://www.nature.com/articles/s41534-024-00898-7</a:t>
             </a:r>
           </a:p>
           <a:p xmlns:a="http://schemas.openxmlformats.org/drawingml/2006/main">
             <a:r>
-              <a:t>https://chatgpt.com/share/6ab672dc-e820-83ea-a2a5-26643690422a</a:t>
-            </a:r>
-          </a:p>
-          <a:p xmlns:a="http://schemas.openxmlformats.org/drawingml/2006/main">
-            <a:r>
-              <a:t>These are proposal gates. No integrated experiment or measured coefficients are claimed.</a:t>
+              <a:t>Operational ratio under the stated diagonal-coupling interpretation. A nonzero result needs systematics and model checks before physical interpretation.</a:t>
             </a:r>
           </a:p>
         </p:txBody>
@@ -649,6 +656,166 @@
 </file>
 
 <file path=ppt/notesSlides/notesSlide12.xml><?xml version="1.0" encoding="utf-8"?>
+<p:notes xmlns:p="http://schemas.openxmlformats.org/presentationml/2006/main">
+  <p:cSld>
+    <p:spTree>
+      <p:nvGrpSpPr>
+        <p:cNvPr id="1" name=""/>
+        <p:cNvGrpSpPr/>
+        <p:nvPr/>
+      </p:nvGrpSpPr>
+      <p:grpSpPr>
+        <a:xfrm xmlns:a="http://schemas.openxmlformats.org/drawingml/2006/main"/>
+      </p:grpSpPr>
+      <p:sp>
+        <p:nvSpPr>
+          <p:cNvPr id="2" name="Slide Image Placeholder 1"/>
+          <p:cNvSpPr>
+            <a:spLocks xmlns:a="http://schemas.openxmlformats.org/drawingml/2006/main" noGrp="1"/>
+          </p:cNvSpPr>
+          <p:nvPr>
+            <p:ph type="sldImg" idx="0"/>
+          </p:nvPr>
+        </p:nvSpPr>
+        <p:spPr/>
+      </p:sp>
+      <p:sp>
+        <p:nvSpPr>
+          <p:cNvPr id="3" name="Notes Placeholder 2"/>
+          <p:cNvSpPr>
+            <a:spLocks xmlns:a="http://schemas.openxmlformats.org/drawingml/2006/main" noGrp="1"/>
+          </p:cNvSpPr>
+          <p:nvPr>
+            <p:ph type="body" idx="1"/>
+          </p:nvPr>
+        </p:nvSpPr>
+        <p:spPr/>
+        <p:txBody>
+          <a:bodyPr xmlns:a="http://schemas.openxmlformats.org/drawingml/2006/main"/>
+          <a:lstStyle xmlns:a="http://schemas.openxmlformats.org/drawingml/2006/main"/>
+          <a:p xmlns:a="http://schemas.openxmlformats.org/drawingml/2006/main">
+            <a:r>
+              <a:t>https://chatgpt.com/share/6ab672dc-e820-83ea-a2a5-26643690422a</a:t>
+            </a:r>
+          </a:p>
+          <a:p xmlns:a="http://schemas.openxmlformats.org/drawingml/2006/main">
+            <a:r>
+              <a:t>https://www.nature.com/articles/s41567-018-0197-6</a:t>
+            </a:r>
+          </a:p>
+          <a:p xmlns:a="http://schemas.openxmlformats.org/drawingml/2006/main">
+            <a:r>
+              <a:t>Each κ± divides corrected measured gravitational phase by a prediction from that encoding's measured spectroscopic gap and an independently measured potential difference.</a:t>
+            </a:r>
+          </a:p>
+        </p:txBody>
+      </p:sp>
+      <p:sp>
+        <p:nvSpPr>
+          <p:cNvPr id="4" name="Slide Number Placeholder 3"/>
+          <p:cNvSpPr>
+            <a:spLocks xmlns:a="http://schemas.openxmlformats.org/drawingml/2006/main" noGrp="1"/>
+          </p:cNvSpPr>
+          <p:nvPr>
+            <p:ph type="sldNum" idx="5"/>
+          </p:nvPr>
+        </p:nvSpPr>
+        <p:spPr/>
+        <p:txBody>
+          <a:bodyPr xmlns:a="http://schemas.openxmlformats.org/drawingml/2006/main"/>
+          <a:lstStyle xmlns:a="http://schemas.openxmlformats.org/drawingml/2006/main"/>
+          <a:p xmlns:a="http://schemas.openxmlformats.org/drawingml/2006/main"/>
+        </p:txBody>
+      </p:sp>
+    </p:spTree>
+  </p:cSld>
+  <p:clrMapOvr>
+    <a:masterClrMapping xmlns:a="http://schemas.openxmlformats.org/drawingml/2006/main"/>
+  </p:clrMapOvr>
+</p:notes>
+</file>
+
+<file path=ppt/notesSlides/notesSlide13.xml><?xml version="1.0" encoding="utf-8"?>
+<p:notes xmlns:p="http://schemas.openxmlformats.org/presentationml/2006/main">
+  <p:cSld>
+    <p:spTree>
+      <p:nvGrpSpPr>
+        <p:cNvPr id="1" name=""/>
+        <p:cNvGrpSpPr/>
+        <p:nvPr/>
+      </p:nvGrpSpPr>
+      <p:grpSpPr>
+        <a:xfrm xmlns:a="http://schemas.openxmlformats.org/drawingml/2006/main"/>
+      </p:grpSpPr>
+      <p:sp>
+        <p:nvSpPr>
+          <p:cNvPr id="2" name="Slide Image Placeholder 1"/>
+          <p:cNvSpPr>
+            <a:spLocks xmlns:a="http://schemas.openxmlformats.org/drawingml/2006/main" noGrp="1"/>
+          </p:cNvSpPr>
+          <p:nvPr>
+            <p:ph type="sldImg" idx="0"/>
+          </p:nvPr>
+        </p:nvSpPr>
+        <p:spPr/>
+      </p:sp>
+      <p:sp>
+        <p:nvSpPr>
+          <p:cNvPr id="3" name="Notes Placeholder 2"/>
+          <p:cNvSpPr>
+            <a:spLocks xmlns:a="http://schemas.openxmlformats.org/drawingml/2006/main" noGrp="1"/>
+          </p:cNvSpPr>
+          <p:nvPr>
+            <p:ph type="body" idx="1"/>
+          </p:nvPr>
+        </p:nvSpPr>
+        <p:spPr/>
+        <p:txBody>
+          <a:bodyPr xmlns:a="http://schemas.openxmlformats.org/drawingml/2006/main"/>
+          <a:lstStyle xmlns:a="http://schemas.openxmlformats.org/drawingml/2006/main"/>
+          <a:p xmlns:a="http://schemas.openxmlformats.org/drawingml/2006/main">
+            <a:r>
+              <a:t>https://www.nature.com/articles/s41534-024-00898-7</a:t>
+            </a:r>
+          </a:p>
+          <a:p xmlns:a="http://schemas.openxmlformats.org/drawingml/2006/main">
+            <a:r>
+              <a:t>https://chatgpt.com/share/6ab672dc-e820-83ea-a2a5-26643690422a</a:t>
+            </a:r>
+          </a:p>
+          <a:p xmlns:a="http://schemas.openxmlformats.org/drawingml/2006/main">
+            <a:r>
+              <a:t>These are proposal gates. No integrated experiment or measured coefficients are claimed.</a:t>
+            </a:r>
+          </a:p>
+        </p:txBody>
+      </p:sp>
+      <p:sp>
+        <p:nvSpPr>
+          <p:cNvPr id="4" name="Slide Number Placeholder 3"/>
+          <p:cNvSpPr>
+            <a:spLocks xmlns:a="http://schemas.openxmlformats.org/drawingml/2006/main" noGrp="1"/>
+          </p:cNvSpPr>
+          <p:nvPr>
+            <p:ph type="sldNum" idx="5"/>
+          </p:nvPr>
+        </p:nvSpPr>
+        <p:spPr/>
+        <p:txBody>
+          <a:bodyPr xmlns:a="http://schemas.openxmlformats.org/drawingml/2006/main"/>
+          <a:lstStyle xmlns:a="http://schemas.openxmlformats.org/drawingml/2006/main"/>
+          <a:p xmlns:a="http://schemas.openxmlformats.org/drawingml/2006/main"/>
+        </p:txBody>
+      </p:sp>
+    </p:spTree>
+  </p:cSld>
+  <p:clrMapOvr>
+    <a:masterClrMapping xmlns:a="http://schemas.openxmlformats.org/drawingml/2006/main"/>
+  </p:clrMapOvr>
+</p:notes>
+</file>
+
+<file path=ppt/notesSlides/notesSlide14.xml><?xml version="1.0" encoding="utf-8"?>
 <p:notes xmlns:p="http://schemas.openxmlformats.org/presentationml/2006/main">
   <p:cSld>
     <p:spTree>
@@ -1396,7 +1563,7 @@
   </p:cSld>
   <p:clrMap bg1="lt1" tx1="dk1" bg2="lt2" tx2="dk2" accent1="accent1" accent2="accent2" accent3="accent3" accent4="accent4" accent5="accent5" accent6="accent6" hlink="hlink" folHlink="folHlink"/>
   <p:sldLayoutIdLst>
-    <p:sldLayoutId xmlns:r="http://schemas.openxmlformats.org/officeDocument/2006/relationships" id="2147483649" r:id="Rbad210c1e25040ac"/>
+    <p:sldLayoutId xmlns:r="http://schemas.openxmlformats.org/officeDocument/2006/relationships" id="2147483649" r:id="Rfc7196e6b5c44dcc"/>
   </p:sldLayoutIdLst>
   <p:txStyles>
     <p:titleStyle>
@@ -1951,7 +2118,7 @@
           <p:nvPr/>
         </p:nvPicPr>
         <p:blipFill>
-          <a:blip xmlns:r="http://schemas.openxmlformats.org/officeDocument/2006/relationships" xmlns:a="http://schemas.openxmlformats.org/drawingml/2006/main" r:embed="R55331036062e46df"/>
+          <a:blip xmlns:r="http://schemas.openxmlformats.org/officeDocument/2006/relationships" xmlns:a="http://schemas.openxmlformats.org/drawingml/2006/main" r:embed="R417d4a3b35724688"/>
           <a:srcRect xmlns:a="http://schemas.openxmlformats.org/drawingml/2006/main" l="0" t="27" r="0" b="27"/>
           <a:stretch xmlns:a="http://schemas.openxmlformats.org/drawingml/2006/main">
             <a:fillRect l="0" t="0" r="0" b="0"/>
@@ -1972,7 +2139,7 @@
           <p:cNvPr id="2" name="">
             <a:extLst xmlns:a="http://schemas.openxmlformats.org/drawingml/2006/main">
               <a:ext uri="{FF2B5EF4-FFF2-40B4-BE49-F238E27FC236}">
-                <a16:creationId xmlns:a16="http://schemas.microsoft.com/office/drawing/2014/main" id="{00CED05A-BB8A-4742-AF1A-E975ECF29A38}"/>
+                <a16:creationId xmlns:a16="http://schemas.microsoft.com/office/drawing/2014/main" id="{871D205E-284E-4712-8588-12C412E5A56B}"/>
               </a:ext>
             </a:extLst>
           </p:cNvPr>
@@ -2052,7 +2219,7 @@
           <p:cNvPr id="3" name="">
             <a:extLst xmlns:a="http://schemas.openxmlformats.org/drawingml/2006/main">
               <a:ext uri="{FF2B5EF4-FFF2-40B4-BE49-F238E27FC236}">
-                <a16:creationId xmlns:a16="http://schemas.microsoft.com/office/drawing/2014/main" id="{747E4379-F12F-4AD6-BAE1-0C2D6BD7BA37}"/>
+                <a16:creationId xmlns:a16="http://schemas.microsoft.com/office/drawing/2014/main" id="{E691EA70-F794-4571-ADEA-EC8386571C8A}"/>
               </a:ext>
             </a:extLst>
           </p:cNvPr>
@@ -2107,7 +2274,7 @@
     </p:spTree>
     <p:extLst>
       <p:ext uri="{BB962C8B-B14F-4D97-AF65-F5344CB8AC3E}">
-        <p14:creationId xmlns:p14="http://schemas.microsoft.com/office/powerpoint/2010/main" val="597646075"/>
+        <p14:creationId xmlns:p14="http://schemas.microsoft.com/office/powerpoint/2010/main" val="936889475"/>
       </p:ext>
     </p:extLst>
   </p:cSld>
@@ -2135,10 +2302,10 @@
       </p:grpSpPr>
       <p:sp>
         <p:nvSpPr>
-          <p:cNvPr id="9" name="">
+          <p:cNvPr id="5" name="">
             <a:extLst xmlns:a="http://schemas.openxmlformats.org/drawingml/2006/main">
               <a:ext uri="{FF2B5EF4-FFF2-40B4-BE49-F238E27FC236}">
-                <a16:creationId xmlns:a16="http://schemas.microsoft.com/office/drawing/2014/main" id="{E0D9B4E6-3A8B-4B53-8414-E0666BE407A5}"/>
+                <a16:creationId xmlns:a16="http://schemas.microsoft.com/office/drawing/2014/main" id="{C92E2470-48EE-47DD-9A07-EB29520B6273}"/>
               </a:ext>
             </a:extLst>
           </p:cNvPr>
@@ -2185,7 +2352,7 @@
                 <a:ea typeface="Arial"/>
                 <a:cs typeface="Arial"/>
               </a:rPr>
-              <a:t>Three dimensionless responses</a:t>
+              <a:t>Ideal phase readout for the two preparations</a:t>
             </a:r>
           </a:p>
         </p:txBody>
@@ -2195,7 +2362,7 @@
           <p:cNvPr id="2" name="">
             <a:extLst xmlns:a="http://schemas.openxmlformats.org/drawingml/2006/main">
               <a:ext uri="{FF2B5EF4-FFF2-40B4-BE49-F238E27FC236}">
-                <a16:creationId xmlns:a16="http://schemas.microsoft.com/office/drawing/2014/main" id="{14ECA4B3-4E0A-442D-AD92-EC05ADC9122F}"/>
+                <a16:creationId xmlns:a16="http://schemas.microsoft.com/office/drawing/2014/main" id="{69448C4D-BE6E-41E9-924A-ED9634DB9E4D}"/>
               </a:ext>
             </a:extLst>
           </p:cNvPr>
@@ -2206,8 +2373,8 @@
         </p:nvSpPr>
         <p:spPr>
           <a:xfrm xmlns:a="http://schemas.openxmlformats.org/drawingml/2006/main">
-            <a:off x="723900" y="1476375"/>
-            <a:ext cx="2095500" cy="666750"/>
+            <a:off x="704850" y="1457325"/>
+            <a:ext cx="10477500" cy="742950"/>
           </a:xfrm>
           <a:prstGeom xmlns:a="http://schemas.openxmlformats.org/drawingml/2006/main" prst="rect">
             <a:avLst/>
@@ -2224,7 +2391,7 @@
           <a:lstStyle xmlns:a="http://schemas.openxmlformats.org/drawingml/2006/main"/>
           <a:p xmlns:a="http://schemas.openxmlformats.org/drawingml/2006/main">
             <a:pPr>
-              <a:defRPr sz="3750" b="1">
+              <a:defRPr sz="3000" b="1">
                 <a:solidFill>
                   <a:srgbClr val="087F8C"/>
                 </a:solidFill>
@@ -2234,7 +2401,7 @@
               </a:defRPr>
             </a:pPr>
             <a:r>
-              <a:rPr sz="3750" b="1">
+              <a:rPr sz="3000" b="1">
                 <a:solidFill>
                   <a:srgbClr val="087F8C"/>
                 </a:solidFill>
@@ -2242,7 +2409,7 @@
                 <a:ea typeface="Arial"/>
                 <a:cs typeface="Arial"/>
               </a:rPr>
-              <a:t>κcl</a:t>
+              <a:t>Πₛ = Cₛ cos(xₛ + sθ − φref)</a:t>
             </a:r>
           </a:p>
         </p:txBody>
@@ -2252,7 +2419,7 @@
           <p:cNvPr id="3" name="">
             <a:extLst xmlns:a="http://schemas.openxmlformats.org/drawingml/2006/main">
               <a:ext uri="{FF2B5EF4-FFF2-40B4-BE49-F238E27FC236}">
-                <a16:creationId xmlns:a16="http://schemas.microsoft.com/office/drawing/2014/main" id="{3A2D6408-EEF9-4E30-B8CB-FEE83A2AFA0F}"/>
+                <a16:creationId xmlns:a16="http://schemas.microsoft.com/office/drawing/2014/main" id="{60874E09-C54D-4A14-9F84-D0678BFA179A}"/>
               </a:ext>
             </a:extLst>
           </p:cNvPr>
@@ -2263,8 +2430,8 @@
         </p:nvSpPr>
         <p:spPr>
           <a:xfrm xmlns:a="http://schemas.openxmlformats.org/drawingml/2006/main">
-            <a:off x="733425" y="2143125"/>
-            <a:ext cx="2952750" cy="533400"/>
+            <a:off x="704850" y="2743200"/>
+            <a:ext cx="10620375" cy="1400175"/>
           </a:xfrm>
           <a:prstGeom xmlns:a="http://schemas.openxmlformats.org/drawingml/2006/main" prst="rect">
             <a:avLst/>
@@ -2281,7 +2448,7 @@
           <a:lstStyle xmlns:a="http://schemas.openxmlformats.org/drawingml/2006/main"/>
           <a:p xmlns:a="http://schemas.openxmlformats.org/drawingml/2006/main">
             <a:pPr>
-              <a:defRPr sz="1875" b="0">
+              <a:defRPr sz="2025" b="0">
                 <a:solidFill>
                   <a:srgbClr val="172C3D"/>
                 </a:solidFill>
@@ -2291,7 +2458,7 @@
               </a:defRPr>
             </a:pPr>
             <a:r>
-              <a:rPr sz="1875" b="0">
+              <a:rPr sz="2025" b="0">
                 <a:solidFill>
                   <a:srgbClr val="172C3D"/>
                 </a:solidFill>
@@ -2299,7 +2466,7 @@
                 <a:ea typeface="Arial"/>
                 <a:cs typeface="Arial"/>
               </a:rPr>
-              <a:t>Conventional clock redshift</a:t>
+              <a:t>With x = 0.5 rad, θ = π/2 and perfect contrast, the predicted probability of matching outcomes is 26.0% for preparation + and 74.0% for preparation −.</a:t>
             </a:r>
           </a:p>
         </p:txBody>
@@ -2309,7 +2476,7 @@
           <p:cNvPr id="4" name="">
             <a:extLst xmlns:a="http://schemas.openxmlformats.org/drawingml/2006/main">
               <a:ext uri="{FF2B5EF4-FFF2-40B4-BE49-F238E27FC236}">
-                <a16:creationId xmlns:a16="http://schemas.microsoft.com/office/drawing/2014/main" id="{B2C2F628-9B74-4A03-9144-36733FD2E0C9}"/>
+                <a16:creationId xmlns:a16="http://schemas.microsoft.com/office/drawing/2014/main" id="{7C0D5C53-EA7C-4253-B9C3-4EA5EAE86028}"/>
               </a:ext>
             </a:extLst>
           </p:cNvPr>
@@ -2320,8 +2487,8 @@
         </p:nvSpPr>
         <p:spPr>
           <a:xfrm xmlns:a="http://schemas.openxmlformats.org/drawingml/2006/main">
-            <a:off x="4333875" y="1476375"/>
-            <a:ext cx="6572250" cy="666750"/>
+            <a:off x="704850" y="5133975"/>
+            <a:ext cx="10620375" cy="904875"/>
           </a:xfrm>
           <a:prstGeom xmlns:a="http://schemas.openxmlformats.org/drawingml/2006/main" prst="rect">
             <a:avLst/>
@@ -2338,9 +2505,9 @@
           <a:lstStyle xmlns:a="http://schemas.openxmlformats.org/drawingml/2006/main"/>
           <a:p xmlns:a="http://schemas.openxmlformats.org/drawingml/2006/main">
             <a:pPr>
-              <a:defRPr sz="3225" b="1">
-                <a:solidFill>
-                  <a:srgbClr val="087F8C"/>
+              <a:defRPr sz="1425" b="0">
+                <a:solidFill>
+                  <a:srgbClr val="536778"/>
                 </a:solidFill>
                 <a:latin typeface="Arial"/>
                 <a:ea typeface="Arial"/>
@@ -2348,243 +2515,15 @@
               </a:defRPr>
             </a:pPr>
             <a:r>
-              <a:rPr sz="3225" b="1">
-                <a:solidFill>
-                  <a:srgbClr val="087F8C"/>
+              <a:rPr sz="1425" b="0">
+                <a:solidFill>
+                  <a:srgbClr val="536778"/>
                 </a:solidFill>
                 <a:latin typeface="Arial"/>
                 <a:ea typeface="Arial"/>
                 <a:cs typeface="Arial"/>
               </a:rPr>
-              <a:t>κ₀ = (κ₊ + κ₋)/2</a:t>
-            </a:r>
-          </a:p>
-        </p:txBody>
-      </p:sp>
-      <p:sp>
-        <p:nvSpPr>
-          <p:cNvPr id="5" name="">
-            <a:extLst xmlns:a="http://schemas.openxmlformats.org/drawingml/2006/main">
-              <a:ext uri="{FF2B5EF4-FFF2-40B4-BE49-F238E27FC236}">
-                <a16:creationId xmlns:a16="http://schemas.microsoft.com/office/drawing/2014/main" id="{390734DC-F522-4401-BB64-AFABC9AC0AC7}"/>
-              </a:ext>
-            </a:extLst>
-          </p:cNvPr>
-          <p:cNvSpPr>
-            <a:spLocks xmlns:a="http://schemas.openxmlformats.org/drawingml/2006/main" noGrp="1"/>
-          </p:cNvSpPr>
-          <p:nvPr/>
-        </p:nvSpPr>
-        <p:spPr>
-          <a:xfrm xmlns:a="http://schemas.openxmlformats.org/drawingml/2006/main">
-            <a:off x="4362450" y="2143125"/>
-            <a:ext cx="5667375" cy="533400"/>
-          </a:xfrm>
-          <a:prstGeom xmlns:a="http://schemas.openxmlformats.org/drawingml/2006/main" prst="rect">
-            <a:avLst/>
-          </a:prstGeom>
-          <a:noFill xmlns:a="http://schemas.openxmlformats.org/drawingml/2006/main"/>
-          <a:ln xmlns:a="http://schemas.openxmlformats.org/drawingml/2006/main" w="0">
-            <a:noFill/>
-          </a:ln>
-        </p:spPr>
-        <p:txBody>
-          <a:bodyPr xmlns:a="http://schemas.openxmlformats.org/drawingml/2006/main" anchor="ctr">
-            <a:noAutofit/>
-          </a:bodyPr>
-          <a:lstStyle xmlns:a="http://schemas.openxmlformats.org/drawingml/2006/main"/>
-          <a:p xmlns:a="http://schemas.openxmlformats.org/drawingml/2006/main">
-            <a:pPr>
-              <a:defRPr sz="1875" b="0">
-                <a:solidFill>
-                  <a:srgbClr val="172C3D"/>
-                </a:solidFill>
-                <a:latin typeface="Arial"/>
-                <a:ea typeface="Arial"/>
-                <a:cs typeface="Arial"/>
-              </a:defRPr>
-            </a:pPr>
-            <a:r>
-              <a:rPr sz="1875" b="0">
-                <a:solidFill>
-                  <a:srgbClr val="172C3D"/>
-                </a:solidFill>
-                <a:latin typeface="Arial"/>
-                <a:ea typeface="Arial"/>
-                <a:cs typeface="Arial"/>
-              </a:rPr>
-              <a:t>Mean correlated response</a:t>
-            </a:r>
-          </a:p>
-        </p:txBody>
-      </p:sp>
-      <p:sp>
-        <p:nvSpPr>
-          <p:cNvPr id="6" name="">
-            <a:extLst xmlns:a="http://schemas.openxmlformats.org/drawingml/2006/main">
-              <a:ext uri="{FF2B5EF4-FFF2-40B4-BE49-F238E27FC236}">
-                <a16:creationId xmlns:a16="http://schemas.microsoft.com/office/drawing/2014/main" id="{F4905637-E5FB-4D98-A7CE-468046DE4E26}"/>
-              </a:ext>
-            </a:extLst>
-          </p:cNvPr>
-          <p:cNvSpPr>
-            <a:spLocks xmlns:a="http://schemas.openxmlformats.org/drawingml/2006/main" noGrp="1"/>
-          </p:cNvSpPr>
-          <p:nvPr/>
-        </p:nvSpPr>
-        <p:spPr>
-          <a:xfrm xmlns:a="http://schemas.openxmlformats.org/drawingml/2006/main">
-            <a:off x="723900" y="3333750"/>
-            <a:ext cx="7620000" cy="666750"/>
-          </a:xfrm>
-          <a:prstGeom xmlns:a="http://schemas.openxmlformats.org/drawingml/2006/main" prst="rect">
-            <a:avLst/>
-          </a:prstGeom>
-          <a:noFill xmlns:a="http://schemas.openxmlformats.org/drawingml/2006/main"/>
-          <a:ln xmlns:a="http://schemas.openxmlformats.org/drawingml/2006/main" w="0">
-            <a:noFill/>
-          </a:ln>
-        </p:spPr>
-        <p:txBody>
-          <a:bodyPr xmlns:a="http://schemas.openxmlformats.org/drawingml/2006/main" anchor="ctr">
-            <a:noAutofit/>
-          </a:bodyPr>
-          <a:lstStyle xmlns:a="http://schemas.openxmlformats.org/drawingml/2006/main"/>
-          <a:p xmlns:a="http://schemas.openxmlformats.org/drawingml/2006/main">
-            <a:pPr>
-              <a:defRPr sz="3225" b="1">
-                <a:solidFill>
-                  <a:srgbClr val="087F8C"/>
-                </a:solidFill>
-                <a:latin typeface="Arial"/>
-                <a:ea typeface="Arial"/>
-                <a:cs typeface="Arial"/>
-              </a:defRPr>
-            </a:pPr>
-            <a:r>
-              <a:rPr sz="3225" b="1">
-                <a:solidFill>
-                  <a:srgbClr val="087F8C"/>
-                </a:solidFill>
-                <a:latin typeface="Arial"/>
-                <a:ea typeface="Arial"/>
-                <a:cs typeface="Arial"/>
-              </a:rPr>
-              <a:t>ηES = (κ₊ − κ₋)/2</a:t>
-            </a:r>
-          </a:p>
-        </p:txBody>
-      </p:sp>
-      <p:sp>
-        <p:nvSpPr>
-          <p:cNvPr id="7" name="">
-            <a:extLst xmlns:a="http://schemas.openxmlformats.org/drawingml/2006/main">
-              <a:ext uri="{FF2B5EF4-FFF2-40B4-BE49-F238E27FC236}">
-                <a16:creationId xmlns:a16="http://schemas.microsoft.com/office/drawing/2014/main" id="{FF168E3A-0D5E-46FD-8770-3AC3FD09EC3D}"/>
-              </a:ext>
-            </a:extLst>
-          </p:cNvPr>
-          <p:cNvSpPr>
-            <a:spLocks xmlns:a="http://schemas.openxmlformats.org/drawingml/2006/main" noGrp="1"/>
-          </p:cNvSpPr>
-          <p:nvPr/>
-        </p:nvSpPr>
-        <p:spPr>
-          <a:xfrm xmlns:a="http://schemas.openxmlformats.org/drawingml/2006/main">
-            <a:off x="733425" y="4000500"/>
-            <a:ext cx="7810500" cy="600075"/>
-          </a:xfrm>
-          <a:prstGeom xmlns:a="http://schemas.openxmlformats.org/drawingml/2006/main" prst="rect">
-            <a:avLst/>
-          </a:prstGeom>
-          <a:noFill xmlns:a="http://schemas.openxmlformats.org/drawingml/2006/main"/>
-          <a:ln xmlns:a="http://schemas.openxmlformats.org/drawingml/2006/main" w="0">
-            <a:noFill/>
-          </a:ln>
-        </p:spPr>
-        <p:txBody>
-          <a:bodyPr xmlns:a="http://schemas.openxmlformats.org/drawingml/2006/main" anchor="ctr">
-            <a:noAutofit/>
-          </a:bodyPr>
-          <a:lstStyle xmlns:a="http://schemas.openxmlformats.org/drawingml/2006/main"/>
-          <a:p xmlns:a="http://schemas.openxmlformats.org/drawingml/2006/main">
-            <a:pPr>
-              <a:defRPr sz="1875" b="0">
-                <a:solidFill>
-                  <a:srgbClr val="172C3D"/>
-                </a:solidFill>
-                <a:latin typeface="Arial"/>
-                <a:ea typeface="Arial"/>
-                <a:cs typeface="Arial"/>
-              </a:defRPr>
-            </a:pPr>
-            <a:r>
-              <a:rPr sz="1875" b="0">
-                <a:solidFill>
-                  <a:srgbClr val="172C3D"/>
-                </a:solidFill>
-                <a:latin typeface="Arial"/>
-                <a:ea typeface="Arial"/>
-                <a:cs typeface="Arial"/>
-              </a:rPr>
-              <a:t>Correlation-dependent half-difference</a:t>
-            </a:r>
-          </a:p>
-        </p:txBody>
-      </p:sp>
-      <p:sp>
-        <p:nvSpPr>
-          <p:cNvPr id="8" name="">
-            <a:extLst xmlns:a="http://schemas.openxmlformats.org/drawingml/2006/main">
-              <a:ext uri="{FF2B5EF4-FFF2-40B4-BE49-F238E27FC236}">
-                <a16:creationId xmlns:a16="http://schemas.microsoft.com/office/drawing/2014/main" id="{7A5F15AF-70A3-4F97-8C36-04733325D431}"/>
-              </a:ext>
-            </a:extLst>
-          </p:cNvPr>
-          <p:cNvSpPr>
-            <a:spLocks xmlns:a="http://schemas.openxmlformats.org/drawingml/2006/main" noGrp="1"/>
-          </p:cNvSpPr>
-          <p:nvPr/>
-        </p:nvSpPr>
-        <p:spPr>
-          <a:xfrm xmlns:a="http://schemas.openxmlformats.org/drawingml/2006/main">
-            <a:off x="704850" y="5219700"/>
-            <a:ext cx="10620375" cy="723900"/>
-          </a:xfrm>
-          <a:prstGeom xmlns:a="http://schemas.openxmlformats.org/drawingml/2006/main" prst="rect">
-            <a:avLst/>
-          </a:prstGeom>
-          <a:noFill xmlns:a="http://schemas.openxmlformats.org/drawingml/2006/main"/>
-          <a:ln xmlns:a="http://schemas.openxmlformats.org/drawingml/2006/main" w="0">
-            <a:noFill/>
-          </a:ln>
-        </p:spPr>
-        <p:txBody>
-          <a:bodyPr xmlns:a="http://schemas.openxmlformats.org/drawingml/2006/main" anchor="ctr">
-            <a:noAutofit/>
-          </a:bodyPr>
-          <a:lstStyle xmlns:a="http://schemas.openxmlformats.org/drawingml/2006/main"/>
-          <a:p xmlns:a="http://schemas.openxmlformats.org/drawingml/2006/main">
-            <a:pPr>
-              <a:defRPr sz="1425" b="0">
-                <a:solidFill>
-                  <a:srgbClr val="536778"/>
-                </a:solidFill>
-                <a:latin typeface="Arial"/>
-                <a:ea typeface="Arial"/>
-                <a:cs typeface="Arial"/>
-              </a:defRPr>
-            </a:pPr>
-            <a:r>
-              <a:rPr sz="1425" b="0">
-                <a:solidFill>
-                  <a:srgbClr val="536778"/>
-                </a:solidFill>
-                <a:latin typeface="Arial"/>
-                <a:ea typeface="Arial"/>
-                <a:cs typeface="Arial"/>
-              </a:rPr>
-              <a:t>Standard prediction: κcl = 1, κ₀ = 1, ηES = 0. These are test coefficients, not established new constants.</a:t>
+              <a:t>That raw difference follows from the analysis control. The test compares the phase inferred from each pattern with its independent gravitational prediction.</a:t>
             </a:r>
           </a:p>
         </p:txBody>
@@ -2592,7 +2531,7 @@
     </p:spTree>
     <p:extLst>
       <p:ext uri="{BB962C8B-B14F-4D97-AF65-F5344CB8AC3E}">
-        <p14:creationId xmlns:p14="http://schemas.microsoft.com/office/powerpoint/2010/main" val="1705053606"/>
+        <p14:creationId xmlns:p14="http://schemas.microsoft.com/office/powerpoint/2010/main" val="256150957"/>
       </p:ext>
     </p:extLst>
   </p:cSld>
@@ -2623,7 +2562,7 @@
           <p:cNvPr id="5" name="">
             <a:extLst xmlns:a="http://schemas.openxmlformats.org/drawingml/2006/main">
               <a:ext uri="{FF2B5EF4-FFF2-40B4-BE49-F238E27FC236}">
-                <a16:creationId xmlns:a16="http://schemas.microsoft.com/office/drawing/2014/main" id="{EA720271-013B-459B-A2B9-0B96C13B9D73}"/>
+                <a16:creationId xmlns:a16="http://schemas.microsoft.com/office/drawing/2014/main" id="{0F0D49CC-D82E-4460-97A0-5316001F0584}"/>
               </a:ext>
             </a:extLst>
           </p:cNvPr>
@@ -2670,7 +2609,7 @@
                 <a:ea typeface="Arial"/>
                 <a:cs typeface="Arial"/>
               </a:rPr>
-              <a:t>What a credible measurement requires</a:t>
+              <a:t>Normalize each measured phase independently</a:t>
             </a:r>
           </a:p>
         </p:txBody>
@@ -2680,7 +2619,7 @@
           <p:cNvPr id="2" name="">
             <a:extLst xmlns:a="http://schemas.openxmlformats.org/drawingml/2006/main">
               <a:ext uri="{FF2B5EF4-FFF2-40B4-BE49-F238E27FC236}">
-                <a16:creationId xmlns:a16="http://schemas.microsoft.com/office/drawing/2014/main" id="{157F2F1E-7D76-47AE-8F06-9005334C8E33}"/>
+                <a16:creationId xmlns:a16="http://schemas.microsoft.com/office/drawing/2014/main" id="{016876CA-BA2F-4E7C-BD4A-B794798F30D4}"/>
               </a:ext>
             </a:extLst>
           </p:cNvPr>
@@ -2691,8 +2630,8 @@
         </p:nvSpPr>
         <p:spPr>
           <a:xfrm xmlns:a="http://schemas.openxmlformats.org/drawingml/2006/main">
-            <a:off x="704850" y="1400175"/>
-            <a:ext cx="10620375" cy="971550"/>
+            <a:off x="704850" y="1533525"/>
+            <a:ext cx="10763250" cy="723900"/>
           </a:xfrm>
           <a:prstGeom xmlns:a="http://schemas.openxmlformats.org/drawingml/2006/main" prst="rect">
             <a:avLst/>
@@ -2709,9 +2648,9 @@
           <a:lstStyle xmlns:a="http://schemas.openxmlformats.org/drawingml/2006/main"/>
           <a:p xmlns:a="http://schemas.openxmlformats.org/drawingml/2006/main">
             <a:pPr>
-              <a:defRPr sz="2025" b="0">
-                <a:solidFill>
-                  <a:srgbClr val="172C3D"/>
+              <a:defRPr sz="2850" b="1">
+                <a:solidFill>
+                  <a:srgbClr val="087F8C"/>
                 </a:solidFill>
                 <a:latin typeface="Arial"/>
                 <a:ea typeface="Arial"/>
@@ -2719,15 +2658,15 @@
               </a:defRPr>
             </a:pPr>
             <a:r>
-              <a:rPr sz="2025" b="0">
-                <a:solidFill>
-                  <a:srgbClr val="172C3D"/>
+              <a:rPr sz="2850" b="1">
+                <a:solidFill>
+                  <a:srgbClr val="087F8C"/>
                 </a:solidFill>
                 <a:latin typeface="Arial"/>
                 <a:ea typeface="Arial"/>
                 <a:cs typeface="Arial"/>
               </a:rPr>
-              <a:t>Independent geometry and gravimetry define the potential. Spectroscopy measures each encoding's true energy gap.</a:t>
+              <a:t>κₛ = xₛ(gravity, measured) / xₛ(GR, predicted)</a:t>
             </a:r>
           </a:p>
         </p:txBody>
@@ -2737,7 +2676,7 @@
           <p:cNvPr id="3" name="">
             <a:extLst xmlns:a="http://schemas.openxmlformats.org/drawingml/2006/main">
               <a:ext uri="{FF2B5EF4-FFF2-40B4-BE49-F238E27FC236}">
-                <a16:creationId xmlns:a16="http://schemas.microsoft.com/office/drawing/2014/main" id="{399BAF13-E2EF-4A4C-A529-029BB73D5D23}"/>
+                <a16:creationId xmlns:a16="http://schemas.microsoft.com/office/drawing/2014/main" id="{ED14D69E-9BDE-4E79-8DA6-5CF16BCCB6FF}"/>
               </a:ext>
             </a:extLst>
           </p:cNvPr>
@@ -2748,8 +2687,8 @@
         </p:nvSpPr>
         <p:spPr>
           <a:xfrm xmlns:a="http://schemas.openxmlformats.org/drawingml/2006/main">
-            <a:off x="704850" y="2752725"/>
-            <a:ext cx="10620375" cy="1162050"/>
+            <a:off x="704850" y="2800350"/>
+            <a:ext cx="10763250" cy="685800"/>
           </a:xfrm>
           <a:prstGeom xmlns:a="http://schemas.openxmlformats.org/drawingml/2006/main" prst="rect">
             <a:avLst/>
@@ -2766,9 +2705,9 @@
           <a:lstStyle xmlns:a="http://schemas.openxmlformats.org/drawingml/2006/main"/>
           <a:p xmlns:a="http://schemas.openxmlformats.org/drawingml/2006/main">
             <a:pPr>
-              <a:defRPr sz="2025" b="0">
-                <a:solidFill>
-                  <a:srgbClr val="172C3D"/>
+              <a:defRPr sz="2700" b="1">
+                <a:solidFill>
+                  <a:srgbClr val="087F8C"/>
                 </a:solidFill>
                 <a:latin typeface="Arial"/>
                 <a:ea typeface="Arial"/>
@@ -2776,15 +2715,15 @@
               </a:defRPr>
             </a:pPr>
             <a:r>
-              <a:rPr sz="2025" b="0">
-                <a:solidFill>
-                  <a:srgbClr val="172C3D"/>
+              <a:rPr sz="2700" b="1">
+                <a:solidFill>
+                  <a:srgbClr val="087F8C"/>
                 </a:solidFill>
                 <a:latin typeface="Arial"/>
                 <a:ea typeface="Arial"/>
                 <a:cs typeface="Arial"/>
               </a:rPr>
-              <a:t>A height scan helps separate gravitational slope from a height-independent frequency offset. Height-dependent field shifts still need calibration.</a:t>
+              <a:t>xₛ(GR, predicted) = (ΔEₛ/ℏ)(ΔU/c²)T</a:t>
             </a:r>
           </a:p>
         </p:txBody>
@@ -2794,7 +2733,7 @@
           <p:cNvPr id="4" name="">
             <a:extLst xmlns:a="http://schemas.openxmlformats.org/drawingml/2006/main">
               <a:ext uri="{FF2B5EF4-FFF2-40B4-BE49-F238E27FC236}">
-                <a16:creationId xmlns:a16="http://schemas.microsoft.com/office/drawing/2014/main" id="{2BF61492-CADC-4417-B003-11C14A2BAC15}"/>
+                <a16:creationId xmlns:a16="http://schemas.microsoft.com/office/drawing/2014/main" id="{8DC63079-897E-49B2-B3AC-5C588F9E15C5}"/>
               </a:ext>
             </a:extLst>
           </p:cNvPr>
@@ -2805,8 +2744,8 @@
         </p:nvSpPr>
         <p:spPr>
           <a:xfrm xmlns:a="http://schemas.openxmlformats.org/drawingml/2006/main">
-            <a:off x="704850" y="4400550"/>
-            <a:ext cx="10620375" cy="1238250"/>
+            <a:off x="704850" y="4381500"/>
+            <a:ext cx="10620375" cy="1333500"/>
           </a:xfrm>
           <a:prstGeom xmlns:a="http://schemas.openxmlformats.org/drawingml/2006/main" prst="rect">
             <a:avLst/>
@@ -2841,7 +2780,7 @@
                 <a:ea typeface="Arial"/>
                 <a:cs typeface="Arial"/>
               </a:rPr>
-              <a:t>Complementary-basis measurements verify Bell coherence. Blinded confirmatory data and a retained covariance model test the fitted response.</a:t>
+              <a:t>Measure each encoding’s ΔEₛ by spectroscopy. Survey ΔU independently. Correct ordinary field and link shifts before extracting the gravitational phase.</a:t>
             </a:r>
           </a:p>
         </p:txBody>
@@ -2849,7 +2788,7 @@
     </p:spTree>
     <p:extLst>
       <p:ext uri="{BB962C8B-B14F-4D97-AF65-F5344CB8AC3E}">
-        <p14:creationId xmlns:p14="http://schemas.microsoft.com/office/powerpoint/2010/main" val="1465803764"/>
+        <p14:creationId xmlns:p14="http://schemas.microsoft.com/office/powerpoint/2010/main" val="1658383762"/>
       </p:ext>
     </p:extLst>
   </p:cSld>
@@ -2877,10 +2816,10 @@
       </p:grpSpPr>
       <p:sp>
         <p:nvSpPr>
-          <p:cNvPr id="5" name="">
+          <p:cNvPr id="9" name="">
             <a:extLst xmlns:a="http://schemas.openxmlformats.org/drawingml/2006/main">
               <a:ext uri="{FF2B5EF4-FFF2-40B4-BE49-F238E27FC236}">
-                <a16:creationId xmlns:a16="http://schemas.microsoft.com/office/drawing/2014/main" id="{069EEC46-B05A-42C7-A634-88DC050D4696}"/>
+                <a16:creationId xmlns:a16="http://schemas.microsoft.com/office/drawing/2014/main" id="{B1A55F82-21BF-42C8-91C7-317855F8EFAA}"/>
               </a:ext>
             </a:extLst>
           </p:cNvPr>
@@ -2927,7 +2866,7 @@
                 <a:ea typeface="Arial"/>
                 <a:cs typeface="Arial"/>
               </a:rPr>
-              <a:t>The proposed closure test</a:t>
+              <a:t>Three dimensionless responses</a:t>
             </a:r>
           </a:p>
         </p:txBody>
@@ -2937,7 +2876,749 @@
           <p:cNvPr id="2" name="">
             <a:extLst xmlns:a="http://schemas.openxmlformats.org/drawingml/2006/main">
               <a:ext uri="{FF2B5EF4-FFF2-40B4-BE49-F238E27FC236}">
-                <a16:creationId xmlns:a16="http://schemas.microsoft.com/office/drawing/2014/main" id="{FF19DAC0-1FB6-49C6-A606-9AF20101E4E3}"/>
+                <a16:creationId xmlns:a16="http://schemas.microsoft.com/office/drawing/2014/main" id="{55A88A90-D0AD-4740-82A2-8A03AD7C1C9D}"/>
+              </a:ext>
+            </a:extLst>
+          </p:cNvPr>
+          <p:cNvSpPr>
+            <a:spLocks xmlns:a="http://schemas.openxmlformats.org/drawingml/2006/main" noGrp="1"/>
+          </p:cNvSpPr>
+          <p:nvPr/>
+        </p:nvSpPr>
+        <p:spPr>
+          <a:xfrm xmlns:a="http://schemas.openxmlformats.org/drawingml/2006/main">
+            <a:off x="723900" y="1476375"/>
+            <a:ext cx="2095500" cy="666750"/>
+          </a:xfrm>
+          <a:prstGeom xmlns:a="http://schemas.openxmlformats.org/drawingml/2006/main" prst="rect">
+            <a:avLst/>
+          </a:prstGeom>
+          <a:noFill xmlns:a="http://schemas.openxmlformats.org/drawingml/2006/main"/>
+          <a:ln xmlns:a="http://schemas.openxmlformats.org/drawingml/2006/main" w="0">
+            <a:noFill/>
+          </a:ln>
+        </p:spPr>
+        <p:txBody>
+          <a:bodyPr xmlns:a="http://schemas.openxmlformats.org/drawingml/2006/main" anchor="ctr">
+            <a:noAutofit/>
+          </a:bodyPr>
+          <a:lstStyle xmlns:a="http://schemas.openxmlformats.org/drawingml/2006/main"/>
+          <a:p xmlns:a="http://schemas.openxmlformats.org/drawingml/2006/main">
+            <a:pPr>
+              <a:defRPr sz="3750" b="1">
+                <a:solidFill>
+                  <a:srgbClr val="087F8C"/>
+                </a:solidFill>
+                <a:latin typeface="Arial"/>
+                <a:ea typeface="Arial"/>
+                <a:cs typeface="Arial"/>
+              </a:defRPr>
+            </a:pPr>
+            <a:r>
+              <a:rPr sz="3750" b="1">
+                <a:solidFill>
+                  <a:srgbClr val="087F8C"/>
+                </a:solidFill>
+                <a:latin typeface="Arial"/>
+                <a:ea typeface="Arial"/>
+                <a:cs typeface="Arial"/>
+              </a:rPr>
+              <a:t>κcl</a:t>
+            </a:r>
+          </a:p>
+        </p:txBody>
+      </p:sp>
+      <p:sp>
+        <p:nvSpPr>
+          <p:cNvPr id="3" name="">
+            <a:extLst xmlns:a="http://schemas.openxmlformats.org/drawingml/2006/main">
+              <a:ext uri="{FF2B5EF4-FFF2-40B4-BE49-F238E27FC236}">
+                <a16:creationId xmlns:a16="http://schemas.microsoft.com/office/drawing/2014/main" id="{9E075B79-0909-4244-B7E9-147E99BC3ABD}"/>
+              </a:ext>
+            </a:extLst>
+          </p:cNvPr>
+          <p:cNvSpPr>
+            <a:spLocks xmlns:a="http://schemas.openxmlformats.org/drawingml/2006/main" noGrp="1"/>
+          </p:cNvSpPr>
+          <p:nvPr/>
+        </p:nvSpPr>
+        <p:spPr>
+          <a:xfrm xmlns:a="http://schemas.openxmlformats.org/drawingml/2006/main">
+            <a:off x="733425" y="2143125"/>
+            <a:ext cx="2952750" cy="533400"/>
+          </a:xfrm>
+          <a:prstGeom xmlns:a="http://schemas.openxmlformats.org/drawingml/2006/main" prst="rect">
+            <a:avLst/>
+          </a:prstGeom>
+          <a:noFill xmlns:a="http://schemas.openxmlformats.org/drawingml/2006/main"/>
+          <a:ln xmlns:a="http://schemas.openxmlformats.org/drawingml/2006/main" w="0">
+            <a:noFill/>
+          </a:ln>
+        </p:spPr>
+        <p:txBody>
+          <a:bodyPr xmlns:a="http://schemas.openxmlformats.org/drawingml/2006/main" anchor="ctr">
+            <a:noAutofit/>
+          </a:bodyPr>
+          <a:lstStyle xmlns:a="http://schemas.openxmlformats.org/drawingml/2006/main"/>
+          <a:p xmlns:a="http://schemas.openxmlformats.org/drawingml/2006/main">
+            <a:pPr>
+              <a:defRPr sz="1875" b="0">
+                <a:solidFill>
+                  <a:srgbClr val="172C3D"/>
+                </a:solidFill>
+                <a:latin typeface="Arial"/>
+                <a:ea typeface="Arial"/>
+                <a:cs typeface="Arial"/>
+              </a:defRPr>
+            </a:pPr>
+            <a:r>
+              <a:rPr sz="1875" b="0">
+                <a:solidFill>
+                  <a:srgbClr val="172C3D"/>
+                </a:solidFill>
+                <a:latin typeface="Arial"/>
+                <a:ea typeface="Arial"/>
+                <a:cs typeface="Arial"/>
+              </a:rPr>
+              <a:t>Conventional clock redshift</a:t>
+            </a:r>
+          </a:p>
+        </p:txBody>
+      </p:sp>
+      <p:sp>
+        <p:nvSpPr>
+          <p:cNvPr id="4" name="">
+            <a:extLst xmlns:a="http://schemas.openxmlformats.org/drawingml/2006/main">
+              <a:ext uri="{FF2B5EF4-FFF2-40B4-BE49-F238E27FC236}">
+                <a16:creationId xmlns:a16="http://schemas.microsoft.com/office/drawing/2014/main" id="{A35ED381-455D-4681-B72A-9EFBBC49B939}"/>
+              </a:ext>
+            </a:extLst>
+          </p:cNvPr>
+          <p:cNvSpPr>
+            <a:spLocks xmlns:a="http://schemas.openxmlformats.org/drawingml/2006/main" noGrp="1"/>
+          </p:cNvSpPr>
+          <p:nvPr/>
+        </p:nvSpPr>
+        <p:spPr>
+          <a:xfrm xmlns:a="http://schemas.openxmlformats.org/drawingml/2006/main">
+            <a:off x="4333875" y="1476375"/>
+            <a:ext cx="6572250" cy="666750"/>
+          </a:xfrm>
+          <a:prstGeom xmlns:a="http://schemas.openxmlformats.org/drawingml/2006/main" prst="rect">
+            <a:avLst/>
+          </a:prstGeom>
+          <a:noFill xmlns:a="http://schemas.openxmlformats.org/drawingml/2006/main"/>
+          <a:ln xmlns:a="http://schemas.openxmlformats.org/drawingml/2006/main" w="0">
+            <a:noFill/>
+          </a:ln>
+        </p:spPr>
+        <p:txBody>
+          <a:bodyPr xmlns:a="http://schemas.openxmlformats.org/drawingml/2006/main" anchor="ctr">
+            <a:noAutofit/>
+          </a:bodyPr>
+          <a:lstStyle xmlns:a="http://schemas.openxmlformats.org/drawingml/2006/main"/>
+          <a:p xmlns:a="http://schemas.openxmlformats.org/drawingml/2006/main">
+            <a:pPr>
+              <a:defRPr sz="3225" b="1">
+                <a:solidFill>
+                  <a:srgbClr val="087F8C"/>
+                </a:solidFill>
+                <a:latin typeface="Arial"/>
+                <a:ea typeface="Arial"/>
+                <a:cs typeface="Arial"/>
+              </a:defRPr>
+            </a:pPr>
+            <a:r>
+              <a:rPr sz="3225" b="1">
+                <a:solidFill>
+                  <a:srgbClr val="087F8C"/>
+                </a:solidFill>
+                <a:latin typeface="Arial"/>
+                <a:ea typeface="Arial"/>
+                <a:cs typeface="Arial"/>
+              </a:rPr>
+              <a:t>κ₀ = (κ₊ + κ₋)/2</a:t>
+            </a:r>
+          </a:p>
+        </p:txBody>
+      </p:sp>
+      <p:sp>
+        <p:nvSpPr>
+          <p:cNvPr id="5" name="">
+            <a:extLst xmlns:a="http://schemas.openxmlformats.org/drawingml/2006/main">
+              <a:ext uri="{FF2B5EF4-FFF2-40B4-BE49-F238E27FC236}">
+                <a16:creationId xmlns:a16="http://schemas.microsoft.com/office/drawing/2014/main" id="{037046D8-753F-49AF-8EFC-0B89E5800817}"/>
+              </a:ext>
+            </a:extLst>
+          </p:cNvPr>
+          <p:cNvSpPr>
+            <a:spLocks xmlns:a="http://schemas.openxmlformats.org/drawingml/2006/main" noGrp="1"/>
+          </p:cNvSpPr>
+          <p:nvPr/>
+        </p:nvSpPr>
+        <p:spPr>
+          <a:xfrm xmlns:a="http://schemas.openxmlformats.org/drawingml/2006/main">
+            <a:off x="4362450" y="2143125"/>
+            <a:ext cx="5667375" cy="533400"/>
+          </a:xfrm>
+          <a:prstGeom xmlns:a="http://schemas.openxmlformats.org/drawingml/2006/main" prst="rect">
+            <a:avLst/>
+          </a:prstGeom>
+          <a:noFill xmlns:a="http://schemas.openxmlformats.org/drawingml/2006/main"/>
+          <a:ln xmlns:a="http://schemas.openxmlformats.org/drawingml/2006/main" w="0">
+            <a:noFill/>
+          </a:ln>
+        </p:spPr>
+        <p:txBody>
+          <a:bodyPr xmlns:a="http://schemas.openxmlformats.org/drawingml/2006/main" anchor="ctr">
+            <a:noAutofit/>
+          </a:bodyPr>
+          <a:lstStyle xmlns:a="http://schemas.openxmlformats.org/drawingml/2006/main"/>
+          <a:p xmlns:a="http://schemas.openxmlformats.org/drawingml/2006/main">
+            <a:pPr>
+              <a:defRPr sz="1875" b="0">
+                <a:solidFill>
+                  <a:srgbClr val="172C3D"/>
+                </a:solidFill>
+                <a:latin typeface="Arial"/>
+                <a:ea typeface="Arial"/>
+                <a:cs typeface="Arial"/>
+              </a:defRPr>
+            </a:pPr>
+            <a:r>
+              <a:rPr sz="1875" b="0">
+                <a:solidFill>
+                  <a:srgbClr val="172C3D"/>
+                </a:solidFill>
+                <a:latin typeface="Arial"/>
+                <a:ea typeface="Arial"/>
+                <a:cs typeface="Arial"/>
+              </a:rPr>
+              <a:t>Mean correlated response</a:t>
+            </a:r>
+          </a:p>
+        </p:txBody>
+      </p:sp>
+      <p:sp>
+        <p:nvSpPr>
+          <p:cNvPr id="6" name="">
+            <a:extLst xmlns:a="http://schemas.openxmlformats.org/drawingml/2006/main">
+              <a:ext uri="{FF2B5EF4-FFF2-40B4-BE49-F238E27FC236}">
+                <a16:creationId xmlns:a16="http://schemas.microsoft.com/office/drawing/2014/main" id="{CDEEBB56-3456-4337-92B8-555B7916A9C8}"/>
+              </a:ext>
+            </a:extLst>
+          </p:cNvPr>
+          <p:cNvSpPr>
+            <a:spLocks xmlns:a="http://schemas.openxmlformats.org/drawingml/2006/main" noGrp="1"/>
+          </p:cNvSpPr>
+          <p:nvPr/>
+        </p:nvSpPr>
+        <p:spPr>
+          <a:xfrm xmlns:a="http://schemas.openxmlformats.org/drawingml/2006/main">
+            <a:off x="723900" y="3333750"/>
+            <a:ext cx="7620000" cy="666750"/>
+          </a:xfrm>
+          <a:prstGeom xmlns:a="http://schemas.openxmlformats.org/drawingml/2006/main" prst="rect">
+            <a:avLst/>
+          </a:prstGeom>
+          <a:noFill xmlns:a="http://schemas.openxmlformats.org/drawingml/2006/main"/>
+          <a:ln xmlns:a="http://schemas.openxmlformats.org/drawingml/2006/main" w="0">
+            <a:noFill/>
+          </a:ln>
+        </p:spPr>
+        <p:txBody>
+          <a:bodyPr xmlns:a="http://schemas.openxmlformats.org/drawingml/2006/main" anchor="ctr">
+            <a:noAutofit/>
+          </a:bodyPr>
+          <a:lstStyle xmlns:a="http://schemas.openxmlformats.org/drawingml/2006/main"/>
+          <a:p xmlns:a="http://schemas.openxmlformats.org/drawingml/2006/main">
+            <a:pPr>
+              <a:defRPr sz="3225" b="1">
+                <a:solidFill>
+                  <a:srgbClr val="087F8C"/>
+                </a:solidFill>
+                <a:latin typeface="Arial"/>
+                <a:ea typeface="Arial"/>
+                <a:cs typeface="Arial"/>
+              </a:defRPr>
+            </a:pPr>
+            <a:r>
+              <a:rPr sz="3225" b="1">
+                <a:solidFill>
+                  <a:srgbClr val="087F8C"/>
+                </a:solidFill>
+                <a:latin typeface="Arial"/>
+                <a:ea typeface="Arial"/>
+                <a:cs typeface="Arial"/>
+              </a:rPr>
+              <a:t>ηES = (κ₊ − κ₋)/2</a:t>
+            </a:r>
+          </a:p>
+        </p:txBody>
+      </p:sp>
+      <p:sp>
+        <p:nvSpPr>
+          <p:cNvPr id="7" name="">
+            <a:extLst xmlns:a="http://schemas.openxmlformats.org/drawingml/2006/main">
+              <a:ext uri="{FF2B5EF4-FFF2-40B4-BE49-F238E27FC236}">
+                <a16:creationId xmlns:a16="http://schemas.microsoft.com/office/drawing/2014/main" id="{603BE128-908D-4BD5-B203-DC946ECF16C9}"/>
+              </a:ext>
+            </a:extLst>
+          </p:cNvPr>
+          <p:cNvSpPr>
+            <a:spLocks xmlns:a="http://schemas.openxmlformats.org/drawingml/2006/main" noGrp="1"/>
+          </p:cNvSpPr>
+          <p:nvPr/>
+        </p:nvSpPr>
+        <p:spPr>
+          <a:xfrm xmlns:a="http://schemas.openxmlformats.org/drawingml/2006/main">
+            <a:off x="733425" y="4000500"/>
+            <a:ext cx="7810500" cy="600075"/>
+          </a:xfrm>
+          <a:prstGeom xmlns:a="http://schemas.openxmlformats.org/drawingml/2006/main" prst="rect">
+            <a:avLst/>
+          </a:prstGeom>
+          <a:noFill xmlns:a="http://schemas.openxmlformats.org/drawingml/2006/main"/>
+          <a:ln xmlns:a="http://schemas.openxmlformats.org/drawingml/2006/main" w="0">
+            <a:noFill/>
+          </a:ln>
+        </p:spPr>
+        <p:txBody>
+          <a:bodyPr xmlns:a="http://schemas.openxmlformats.org/drawingml/2006/main" anchor="ctr">
+            <a:noAutofit/>
+          </a:bodyPr>
+          <a:lstStyle xmlns:a="http://schemas.openxmlformats.org/drawingml/2006/main"/>
+          <a:p xmlns:a="http://schemas.openxmlformats.org/drawingml/2006/main">
+            <a:pPr>
+              <a:defRPr sz="1875" b="0">
+                <a:solidFill>
+                  <a:srgbClr val="172C3D"/>
+                </a:solidFill>
+                <a:latin typeface="Arial"/>
+                <a:ea typeface="Arial"/>
+                <a:cs typeface="Arial"/>
+              </a:defRPr>
+            </a:pPr>
+            <a:r>
+              <a:rPr sz="1875" b="0">
+                <a:solidFill>
+                  <a:srgbClr val="172C3D"/>
+                </a:solidFill>
+                <a:latin typeface="Arial"/>
+                <a:ea typeface="Arial"/>
+                <a:cs typeface="Arial"/>
+              </a:rPr>
+              <a:t>Correlation-dependent half-difference</a:t>
+            </a:r>
+          </a:p>
+        </p:txBody>
+      </p:sp>
+      <p:sp>
+        <p:nvSpPr>
+          <p:cNvPr id="8" name="">
+            <a:extLst xmlns:a="http://schemas.openxmlformats.org/drawingml/2006/main">
+              <a:ext uri="{FF2B5EF4-FFF2-40B4-BE49-F238E27FC236}">
+                <a16:creationId xmlns:a16="http://schemas.microsoft.com/office/drawing/2014/main" id="{FB024968-E596-437D-BA69-90D583FFA67A}"/>
+              </a:ext>
+            </a:extLst>
+          </p:cNvPr>
+          <p:cNvSpPr>
+            <a:spLocks xmlns:a="http://schemas.openxmlformats.org/drawingml/2006/main" noGrp="1"/>
+          </p:cNvSpPr>
+          <p:nvPr/>
+        </p:nvSpPr>
+        <p:spPr>
+          <a:xfrm xmlns:a="http://schemas.openxmlformats.org/drawingml/2006/main">
+            <a:off x="704850" y="5219700"/>
+            <a:ext cx="10620375" cy="723900"/>
+          </a:xfrm>
+          <a:prstGeom xmlns:a="http://schemas.openxmlformats.org/drawingml/2006/main" prst="rect">
+            <a:avLst/>
+          </a:prstGeom>
+          <a:noFill xmlns:a="http://schemas.openxmlformats.org/drawingml/2006/main"/>
+          <a:ln xmlns:a="http://schemas.openxmlformats.org/drawingml/2006/main" w="0">
+            <a:noFill/>
+          </a:ln>
+        </p:spPr>
+        <p:txBody>
+          <a:bodyPr xmlns:a="http://schemas.openxmlformats.org/drawingml/2006/main" anchor="ctr">
+            <a:noAutofit/>
+          </a:bodyPr>
+          <a:lstStyle xmlns:a="http://schemas.openxmlformats.org/drawingml/2006/main"/>
+          <a:p xmlns:a="http://schemas.openxmlformats.org/drawingml/2006/main">
+            <a:pPr>
+              <a:defRPr sz="1425" b="0">
+                <a:solidFill>
+                  <a:srgbClr val="536778"/>
+                </a:solidFill>
+                <a:latin typeface="Arial"/>
+                <a:ea typeface="Arial"/>
+                <a:cs typeface="Arial"/>
+              </a:defRPr>
+            </a:pPr>
+            <a:r>
+              <a:rPr sz="1425" b="0">
+                <a:solidFill>
+                  <a:srgbClr val="536778"/>
+                </a:solidFill>
+                <a:latin typeface="Arial"/>
+                <a:ea typeface="Arial"/>
+                <a:cs typeface="Arial"/>
+              </a:rPr>
+              <a:t>Standard prediction: κcl = 1, κ₀ = 1, ηES = 0. These are test coefficients, not established new constants.</a:t>
+            </a:r>
+          </a:p>
+        </p:txBody>
+      </p:sp>
+    </p:spTree>
+    <p:extLst>
+      <p:ext uri="{BB962C8B-B14F-4D97-AF65-F5344CB8AC3E}">
+        <p14:creationId xmlns:p14="http://schemas.microsoft.com/office/powerpoint/2010/main" val="785109382"/>
+      </p:ext>
+    </p:extLst>
+  </p:cSld>
+</p:sld>
+</file>
+
+<file path=ppt/slides/slide13.xml><?xml version="1.0" encoding="utf-8"?>
+<p:sld xmlns:p="http://schemas.openxmlformats.org/presentationml/2006/main">
+  <p:cSld>
+    <p:bg>
+      <p:bgPr>
+        <a:solidFill xmlns:a="http://schemas.openxmlformats.org/drawingml/2006/main">
+          <a:srgbClr val="FFFFFF"/>
+        </a:solidFill>
+      </p:bgPr>
+    </p:bg>
+    <p:spTree>
+      <p:nvGrpSpPr>
+        <p:cNvPr id="1" name=""/>
+        <p:cNvGrpSpPr/>
+        <p:nvPr/>
+      </p:nvGrpSpPr>
+      <p:grpSpPr>
+        <a:xfrm xmlns:a="http://schemas.openxmlformats.org/drawingml/2006/main"/>
+      </p:grpSpPr>
+      <p:sp>
+        <p:nvSpPr>
+          <p:cNvPr id="5" name="">
+            <a:extLst xmlns:a="http://schemas.openxmlformats.org/drawingml/2006/main">
+              <a:ext uri="{FF2B5EF4-FFF2-40B4-BE49-F238E27FC236}">
+                <a16:creationId xmlns:a16="http://schemas.microsoft.com/office/drawing/2014/main" id="{0806D558-FB8B-4E25-8445-A1D96DAD1055}"/>
+              </a:ext>
+            </a:extLst>
+          </p:cNvPr>
+          <p:cNvSpPr>
+            <a:spLocks xmlns:a="http://schemas.openxmlformats.org/drawingml/2006/main" noGrp="1"/>
+          </p:cNvSpPr>
+          <p:nvPr/>
+        </p:nvSpPr>
+        <p:spPr>
+          <a:xfrm xmlns:a="http://schemas.openxmlformats.org/drawingml/2006/main">
+            <a:off x="609600" y="352425"/>
+            <a:ext cx="10906125" cy="676275"/>
+          </a:xfrm>
+          <a:prstGeom xmlns:a="http://schemas.openxmlformats.org/drawingml/2006/main" prst="rect">
+            <a:avLst/>
+          </a:prstGeom>
+          <a:noFill xmlns:a="http://schemas.openxmlformats.org/drawingml/2006/main"/>
+          <a:ln xmlns:a="http://schemas.openxmlformats.org/drawingml/2006/main" w="0">
+            <a:noFill/>
+          </a:ln>
+        </p:spPr>
+        <p:txBody>
+          <a:bodyPr xmlns:a="http://schemas.openxmlformats.org/drawingml/2006/main" anchor="ctr">
+            <a:noAutofit/>
+          </a:bodyPr>
+          <a:lstStyle xmlns:a="http://schemas.openxmlformats.org/drawingml/2006/main"/>
+          <a:p xmlns:a="http://schemas.openxmlformats.org/drawingml/2006/main">
+            <a:pPr>
+              <a:defRPr sz="2700" b="1">
+                <a:solidFill>
+                  <a:srgbClr val="102238"/>
+                </a:solidFill>
+                <a:latin typeface="Arial"/>
+                <a:ea typeface="Arial"/>
+                <a:cs typeface="Arial"/>
+              </a:defRPr>
+            </a:pPr>
+            <a:r>
+              <a:rPr sz="2700" b="1">
+                <a:solidFill>
+                  <a:srgbClr val="102238"/>
+                </a:solidFill>
+                <a:latin typeface="Arial"/>
+                <a:ea typeface="Arial"/>
+                <a:cs typeface="Arial"/>
+              </a:rPr>
+              <a:t>What a credible measurement requires</a:t>
+            </a:r>
+          </a:p>
+        </p:txBody>
+      </p:sp>
+      <p:sp>
+        <p:nvSpPr>
+          <p:cNvPr id="2" name="">
+            <a:extLst xmlns:a="http://schemas.openxmlformats.org/drawingml/2006/main">
+              <a:ext uri="{FF2B5EF4-FFF2-40B4-BE49-F238E27FC236}">
+                <a16:creationId xmlns:a16="http://schemas.microsoft.com/office/drawing/2014/main" id="{64583986-7588-4C6F-AD36-3E8A32DA9E7C}"/>
+              </a:ext>
+            </a:extLst>
+          </p:cNvPr>
+          <p:cNvSpPr>
+            <a:spLocks xmlns:a="http://schemas.openxmlformats.org/drawingml/2006/main" noGrp="1"/>
+          </p:cNvSpPr>
+          <p:nvPr/>
+        </p:nvSpPr>
+        <p:spPr>
+          <a:xfrm xmlns:a="http://schemas.openxmlformats.org/drawingml/2006/main">
+            <a:off x="704850" y="1400175"/>
+            <a:ext cx="10620375" cy="971550"/>
+          </a:xfrm>
+          <a:prstGeom xmlns:a="http://schemas.openxmlformats.org/drawingml/2006/main" prst="rect">
+            <a:avLst/>
+          </a:prstGeom>
+          <a:noFill xmlns:a="http://schemas.openxmlformats.org/drawingml/2006/main"/>
+          <a:ln xmlns:a="http://schemas.openxmlformats.org/drawingml/2006/main" w="0">
+            <a:noFill/>
+          </a:ln>
+        </p:spPr>
+        <p:txBody>
+          <a:bodyPr xmlns:a="http://schemas.openxmlformats.org/drawingml/2006/main" anchor="ctr">
+            <a:noAutofit/>
+          </a:bodyPr>
+          <a:lstStyle xmlns:a="http://schemas.openxmlformats.org/drawingml/2006/main"/>
+          <a:p xmlns:a="http://schemas.openxmlformats.org/drawingml/2006/main">
+            <a:pPr>
+              <a:defRPr sz="2025" b="0">
+                <a:solidFill>
+                  <a:srgbClr val="172C3D"/>
+                </a:solidFill>
+                <a:latin typeface="Arial"/>
+                <a:ea typeface="Arial"/>
+                <a:cs typeface="Arial"/>
+              </a:defRPr>
+            </a:pPr>
+            <a:r>
+              <a:rPr sz="2025" b="0">
+                <a:solidFill>
+                  <a:srgbClr val="172C3D"/>
+                </a:solidFill>
+                <a:latin typeface="Arial"/>
+                <a:ea typeface="Arial"/>
+                <a:cs typeface="Arial"/>
+              </a:rPr>
+              <a:t>Independent geometry and gravimetry define the potential. Spectroscopy measures each encoding's true energy gap.</a:t>
+            </a:r>
+          </a:p>
+        </p:txBody>
+      </p:sp>
+      <p:sp>
+        <p:nvSpPr>
+          <p:cNvPr id="3" name="">
+            <a:extLst xmlns:a="http://schemas.openxmlformats.org/drawingml/2006/main">
+              <a:ext uri="{FF2B5EF4-FFF2-40B4-BE49-F238E27FC236}">
+                <a16:creationId xmlns:a16="http://schemas.microsoft.com/office/drawing/2014/main" id="{865A1987-2975-48E4-8D97-B64F95C80627}"/>
+              </a:ext>
+            </a:extLst>
+          </p:cNvPr>
+          <p:cNvSpPr>
+            <a:spLocks xmlns:a="http://schemas.openxmlformats.org/drawingml/2006/main" noGrp="1"/>
+          </p:cNvSpPr>
+          <p:nvPr/>
+        </p:nvSpPr>
+        <p:spPr>
+          <a:xfrm xmlns:a="http://schemas.openxmlformats.org/drawingml/2006/main">
+            <a:off x="704850" y="2752725"/>
+            <a:ext cx="10620375" cy="1162050"/>
+          </a:xfrm>
+          <a:prstGeom xmlns:a="http://schemas.openxmlformats.org/drawingml/2006/main" prst="rect">
+            <a:avLst/>
+          </a:prstGeom>
+          <a:noFill xmlns:a="http://schemas.openxmlformats.org/drawingml/2006/main"/>
+          <a:ln xmlns:a="http://schemas.openxmlformats.org/drawingml/2006/main" w="0">
+            <a:noFill/>
+          </a:ln>
+        </p:spPr>
+        <p:txBody>
+          <a:bodyPr xmlns:a="http://schemas.openxmlformats.org/drawingml/2006/main" anchor="ctr">
+            <a:noAutofit/>
+          </a:bodyPr>
+          <a:lstStyle xmlns:a="http://schemas.openxmlformats.org/drawingml/2006/main"/>
+          <a:p xmlns:a="http://schemas.openxmlformats.org/drawingml/2006/main">
+            <a:pPr>
+              <a:defRPr sz="2025" b="0">
+                <a:solidFill>
+                  <a:srgbClr val="172C3D"/>
+                </a:solidFill>
+                <a:latin typeface="Arial"/>
+                <a:ea typeface="Arial"/>
+                <a:cs typeface="Arial"/>
+              </a:defRPr>
+            </a:pPr>
+            <a:r>
+              <a:rPr sz="2025" b="0">
+                <a:solidFill>
+                  <a:srgbClr val="172C3D"/>
+                </a:solidFill>
+                <a:latin typeface="Arial"/>
+                <a:ea typeface="Arial"/>
+                <a:cs typeface="Arial"/>
+              </a:rPr>
+              <a:t>A height scan helps separate gravitational slope from a height-independent frequency offset. Height-dependent field shifts still need calibration.</a:t>
+            </a:r>
+          </a:p>
+        </p:txBody>
+      </p:sp>
+      <p:sp>
+        <p:nvSpPr>
+          <p:cNvPr id="4" name="">
+            <a:extLst xmlns:a="http://schemas.openxmlformats.org/drawingml/2006/main">
+              <a:ext uri="{FF2B5EF4-FFF2-40B4-BE49-F238E27FC236}">
+                <a16:creationId xmlns:a16="http://schemas.microsoft.com/office/drawing/2014/main" id="{47CA6CE2-703D-4028-BF2A-CA89AF54C139}"/>
+              </a:ext>
+            </a:extLst>
+          </p:cNvPr>
+          <p:cNvSpPr>
+            <a:spLocks xmlns:a="http://schemas.openxmlformats.org/drawingml/2006/main" noGrp="1"/>
+          </p:cNvSpPr>
+          <p:nvPr/>
+        </p:nvSpPr>
+        <p:spPr>
+          <a:xfrm xmlns:a="http://schemas.openxmlformats.org/drawingml/2006/main">
+            <a:off x="704850" y="4400550"/>
+            <a:ext cx="10620375" cy="1238250"/>
+          </a:xfrm>
+          <a:prstGeom xmlns:a="http://schemas.openxmlformats.org/drawingml/2006/main" prst="rect">
+            <a:avLst/>
+          </a:prstGeom>
+          <a:noFill xmlns:a="http://schemas.openxmlformats.org/drawingml/2006/main"/>
+          <a:ln xmlns:a="http://schemas.openxmlformats.org/drawingml/2006/main" w="0">
+            <a:noFill/>
+          </a:ln>
+        </p:spPr>
+        <p:txBody>
+          <a:bodyPr xmlns:a="http://schemas.openxmlformats.org/drawingml/2006/main" anchor="ctr">
+            <a:noAutofit/>
+          </a:bodyPr>
+          <a:lstStyle xmlns:a="http://schemas.openxmlformats.org/drawingml/2006/main"/>
+          <a:p xmlns:a="http://schemas.openxmlformats.org/drawingml/2006/main">
+            <a:pPr>
+              <a:defRPr sz="2025" b="0">
+                <a:solidFill>
+                  <a:srgbClr val="172C3D"/>
+                </a:solidFill>
+                <a:latin typeface="Arial"/>
+                <a:ea typeface="Arial"/>
+                <a:cs typeface="Arial"/>
+              </a:defRPr>
+            </a:pPr>
+            <a:r>
+              <a:rPr sz="2025" b="0">
+                <a:solidFill>
+                  <a:srgbClr val="172C3D"/>
+                </a:solidFill>
+                <a:latin typeface="Arial"/>
+                <a:ea typeface="Arial"/>
+                <a:cs typeface="Arial"/>
+              </a:rPr>
+              <a:t>Complementary-basis measurements verify Bell coherence. Blinded confirmatory data and a retained covariance model test the fitted response.</a:t>
+            </a:r>
+          </a:p>
+        </p:txBody>
+      </p:sp>
+    </p:spTree>
+    <p:extLst>
+      <p:ext uri="{BB962C8B-B14F-4D97-AF65-F5344CB8AC3E}">
+        <p14:creationId xmlns:p14="http://schemas.microsoft.com/office/powerpoint/2010/main" val="1418562608"/>
+      </p:ext>
+    </p:extLst>
+  </p:cSld>
+</p:sld>
+</file>
+
+<file path=ppt/slides/slide14.xml><?xml version="1.0" encoding="utf-8"?>
+<p:sld xmlns:p="http://schemas.openxmlformats.org/presentationml/2006/main">
+  <p:cSld>
+    <p:bg>
+      <p:bgPr>
+        <a:solidFill xmlns:a="http://schemas.openxmlformats.org/drawingml/2006/main">
+          <a:srgbClr val="FFFFFF"/>
+        </a:solidFill>
+      </p:bgPr>
+    </p:bg>
+    <p:spTree>
+      <p:nvGrpSpPr>
+        <p:cNvPr id="1" name=""/>
+        <p:cNvGrpSpPr/>
+        <p:nvPr/>
+      </p:nvGrpSpPr>
+      <p:grpSpPr>
+        <a:xfrm xmlns:a="http://schemas.openxmlformats.org/drawingml/2006/main"/>
+      </p:grpSpPr>
+      <p:sp>
+        <p:nvSpPr>
+          <p:cNvPr id="5" name="">
+            <a:extLst xmlns:a="http://schemas.openxmlformats.org/drawingml/2006/main">
+              <a:ext uri="{FF2B5EF4-FFF2-40B4-BE49-F238E27FC236}">
+                <a16:creationId xmlns:a16="http://schemas.microsoft.com/office/drawing/2014/main" id="{164BFD1A-9EF8-4112-822C-359AEE0838F1}"/>
+              </a:ext>
+            </a:extLst>
+          </p:cNvPr>
+          <p:cNvSpPr>
+            <a:spLocks xmlns:a="http://schemas.openxmlformats.org/drawingml/2006/main" noGrp="1"/>
+          </p:cNvSpPr>
+          <p:nvPr/>
+        </p:nvSpPr>
+        <p:spPr>
+          <a:xfrm xmlns:a="http://schemas.openxmlformats.org/drawingml/2006/main">
+            <a:off x="609600" y="352425"/>
+            <a:ext cx="10906125" cy="676275"/>
+          </a:xfrm>
+          <a:prstGeom xmlns:a="http://schemas.openxmlformats.org/drawingml/2006/main" prst="rect">
+            <a:avLst/>
+          </a:prstGeom>
+          <a:noFill xmlns:a="http://schemas.openxmlformats.org/drawingml/2006/main"/>
+          <a:ln xmlns:a="http://schemas.openxmlformats.org/drawingml/2006/main" w="0">
+            <a:noFill/>
+          </a:ln>
+        </p:spPr>
+        <p:txBody>
+          <a:bodyPr xmlns:a="http://schemas.openxmlformats.org/drawingml/2006/main" anchor="ctr">
+            <a:noAutofit/>
+          </a:bodyPr>
+          <a:lstStyle xmlns:a="http://schemas.openxmlformats.org/drawingml/2006/main"/>
+          <a:p xmlns:a="http://schemas.openxmlformats.org/drawingml/2006/main">
+            <a:pPr>
+              <a:defRPr sz="2700" b="1">
+                <a:solidFill>
+                  <a:srgbClr val="102238"/>
+                </a:solidFill>
+                <a:latin typeface="Arial"/>
+                <a:ea typeface="Arial"/>
+                <a:cs typeface="Arial"/>
+              </a:defRPr>
+            </a:pPr>
+            <a:r>
+              <a:rPr sz="2700" b="1">
+                <a:solidFill>
+                  <a:srgbClr val="102238"/>
+                </a:solidFill>
+                <a:latin typeface="Arial"/>
+                <a:ea typeface="Arial"/>
+                <a:cs typeface="Arial"/>
+              </a:rPr>
+              <a:t>The proposed closure test</a:t>
+            </a:r>
+          </a:p>
+        </p:txBody>
+      </p:sp>
+      <p:sp>
+        <p:nvSpPr>
+          <p:cNvPr id="2" name="">
+            <a:extLst xmlns:a="http://schemas.openxmlformats.org/drawingml/2006/main">
+              <a:ext uri="{FF2B5EF4-FFF2-40B4-BE49-F238E27FC236}">
+                <a16:creationId xmlns:a16="http://schemas.microsoft.com/office/drawing/2014/main" id="{D8971FD0-56F1-40AD-A29E-DCDCA30CDF6E}"/>
               </a:ext>
             </a:extLst>
           </p:cNvPr>
@@ -2994,7 +3675,7 @@
           <p:cNvPr id="3" name="">
             <a:extLst xmlns:a="http://schemas.openxmlformats.org/drawingml/2006/main">
               <a:ext uri="{FF2B5EF4-FFF2-40B4-BE49-F238E27FC236}">
-                <a16:creationId xmlns:a16="http://schemas.microsoft.com/office/drawing/2014/main" id="{CB7A0950-4C83-4FAF-992C-08C2932C1548}"/>
+                <a16:creationId xmlns:a16="http://schemas.microsoft.com/office/drawing/2014/main" id="{312A0D3D-933A-4805-A40F-A9DF364F9DAC}"/>
               </a:ext>
             </a:extLst>
           </p:cNvPr>
@@ -3051,7 +3732,7 @@
           <p:cNvPr id="4" name="">
             <a:extLst xmlns:a="http://schemas.openxmlformats.org/drawingml/2006/main">
               <a:ext uri="{FF2B5EF4-FFF2-40B4-BE49-F238E27FC236}">
-                <a16:creationId xmlns:a16="http://schemas.microsoft.com/office/drawing/2014/main" id="{8B40E2F8-7A1C-4B5E-AB5A-277C21FB5093}"/>
+                <a16:creationId xmlns:a16="http://schemas.microsoft.com/office/drawing/2014/main" id="{EFEE141F-B962-454A-973F-FAE23F68BE53}"/>
               </a:ext>
             </a:extLst>
           </p:cNvPr>
@@ -3106,7 +3787,7 @@
     </p:spTree>
     <p:extLst>
       <p:ext uri="{BB962C8B-B14F-4D97-AF65-F5344CB8AC3E}">
-        <p14:creationId xmlns:p14="http://schemas.microsoft.com/office/powerpoint/2010/main" val="1190580455"/>
+        <p14:creationId xmlns:p14="http://schemas.microsoft.com/office/powerpoint/2010/main" val="1839259694"/>
       </p:ext>
     </p:extLst>
   </p:cSld>
@@ -3137,7 +3818,7 @@
           <p:cNvPr id="5" name="">
             <a:extLst xmlns:a="http://schemas.openxmlformats.org/drawingml/2006/main">
               <a:ext uri="{FF2B5EF4-FFF2-40B4-BE49-F238E27FC236}">
-                <a16:creationId xmlns:a16="http://schemas.microsoft.com/office/drawing/2014/main" id="{E641A3E8-E60B-4234-A0BF-D5432D8F465A}"/>
+                <a16:creationId xmlns:a16="http://schemas.microsoft.com/office/drawing/2014/main" id="{B81DB2CD-E7DD-4006-BA1F-85553DB81B7C}"/>
               </a:ext>
             </a:extLst>
           </p:cNvPr>
@@ -3194,7 +3875,7 @@
           <p:cNvPr id="2" name="">
             <a:extLst xmlns:a="http://schemas.openxmlformats.org/drawingml/2006/main">
               <a:ext uri="{FF2B5EF4-FFF2-40B4-BE49-F238E27FC236}">
-                <a16:creationId xmlns:a16="http://schemas.microsoft.com/office/drawing/2014/main" id="{9523C318-E726-4D98-8270-D564554F709B}"/>
+                <a16:creationId xmlns:a16="http://schemas.microsoft.com/office/drawing/2014/main" id="{7E9EC7D4-41B6-471F-9BD4-A65A5F7EDA9B}"/>
               </a:ext>
             </a:extLst>
           </p:cNvPr>
@@ -3251,7 +3932,7 @@
           <p:cNvPr id="3" name="">
             <a:extLst xmlns:a="http://schemas.openxmlformats.org/drawingml/2006/main">
               <a:ext uri="{FF2B5EF4-FFF2-40B4-BE49-F238E27FC236}">
-                <a16:creationId xmlns:a16="http://schemas.microsoft.com/office/drawing/2014/main" id="{B335CB81-0189-4316-8E15-71CC4A9CD724}"/>
+                <a16:creationId xmlns:a16="http://schemas.microsoft.com/office/drawing/2014/main" id="{C5D70E7F-4527-4E3C-86B3-3CE1A14DCBFF}"/>
               </a:ext>
             </a:extLst>
           </p:cNvPr>
@@ -3308,7 +3989,7 @@
           <p:cNvPr id="4" name="">
             <a:extLst xmlns:a="http://schemas.openxmlformats.org/drawingml/2006/main">
               <a:ext uri="{FF2B5EF4-FFF2-40B4-BE49-F238E27FC236}">
-                <a16:creationId xmlns:a16="http://schemas.microsoft.com/office/drawing/2014/main" id="{57D3AF37-9EB9-4048-9A77-4050D7E4B25E}"/>
+                <a16:creationId xmlns:a16="http://schemas.microsoft.com/office/drawing/2014/main" id="{F81738D7-D174-4BDD-9CB4-54F47336F2BD}"/>
               </a:ext>
             </a:extLst>
           </p:cNvPr>
@@ -3363,7 +4044,7 @@
     </p:spTree>
     <p:extLst>
       <p:ext uri="{BB962C8B-B14F-4D97-AF65-F5344CB8AC3E}">
-        <p14:creationId xmlns:p14="http://schemas.microsoft.com/office/powerpoint/2010/main" val="983669265"/>
+        <p14:creationId xmlns:p14="http://schemas.microsoft.com/office/powerpoint/2010/main" val="561731370"/>
       </p:ext>
     </p:extLst>
   </p:cSld>
@@ -3394,7 +4075,7 @@
           <p:cNvPr id="5" name="">
             <a:extLst xmlns:a="http://schemas.openxmlformats.org/drawingml/2006/main">
               <a:ext uri="{FF2B5EF4-FFF2-40B4-BE49-F238E27FC236}">
-                <a16:creationId xmlns:a16="http://schemas.microsoft.com/office/drawing/2014/main" id="{FBFC5608-C2FA-47C0-8C8F-229A0871A107}"/>
+                <a16:creationId xmlns:a16="http://schemas.microsoft.com/office/drawing/2014/main" id="{F4343A49-7B12-46A5-B590-467E33D95643}"/>
               </a:ext>
             </a:extLst>
           </p:cNvPr>
@@ -3451,7 +4132,7 @@
           <p:cNvPr id="2" name="">
             <a:extLst xmlns:a="http://schemas.openxmlformats.org/drawingml/2006/main">
               <a:ext uri="{FF2B5EF4-FFF2-40B4-BE49-F238E27FC236}">
-                <a16:creationId xmlns:a16="http://schemas.microsoft.com/office/drawing/2014/main" id="{41EE7E09-4432-4E17-8F33-58BA30B30A5E}"/>
+                <a16:creationId xmlns:a16="http://schemas.microsoft.com/office/drawing/2014/main" id="{13AF1E9A-A691-4E96-8D4A-1766AE631594}"/>
               </a:ext>
             </a:extLst>
           </p:cNvPr>
@@ -3975,7 +4656,7 @@
           <p:cNvPr id="4" name="">
             <a:extLst xmlns:a="http://schemas.openxmlformats.org/drawingml/2006/main">
               <a:ext uri="{FF2B5EF4-FFF2-40B4-BE49-F238E27FC236}">
-                <a16:creationId xmlns:a16="http://schemas.microsoft.com/office/drawing/2014/main" id="{5FAE725B-03AB-4871-8F79-F4B7FF844D8B}"/>
+                <a16:creationId xmlns:a16="http://schemas.microsoft.com/office/drawing/2014/main" id="{ED02E4C3-A043-4331-8732-24ACD2EEE40A}"/>
               </a:ext>
             </a:extLst>
           </p:cNvPr>
@@ -4030,7 +4711,7 @@
     </p:spTree>
     <p:extLst>
       <p:ext uri="{BB962C8B-B14F-4D97-AF65-F5344CB8AC3E}">
-        <p14:creationId xmlns:p14="http://schemas.microsoft.com/office/powerpoint/2010/main" val="1512910469"/>
+        <p14:creationId xmlns:p14="http://schemas.microsoft.com/office/powerpoint/2010/main" val="1234169277"/>
       </p:ext>
     </p:extLst>
   </p:cSld>
@@ -4061,7 +4742,7 @@
           <p:cNvPr id="6" name="">
             <a:extLst xmlns:a="http://schemas.openxmlformats.org/drawingml/2006/main">
               <a:ext uri="{FF2B5EF4-FFF2-40B4-BE49-F238E27FC236}">
-                <a16:creationId xmlns:a16="http://schemas.microsoft.com/office/drawing/2014/main" id="{1CEA3FE6-788E-47AC-BC22-FED980512FFB}"/>
+                <a16:creationId xmlns:a16="http://schemas.microsoft.com/office/drawing/2014/main" id="{B1DE072B-56B9-45BE-85EE-69E2CB97FBE9}"/>
               </a:ext>
             </a:extLst>
           </p:cNvPr>
@@ -4118,7 +4799,7 @@
           <p:cNvPr id="2" name="">
             <a:extLst xmlns:a="http://schemas.openxmlformats.org/drawingml/2006/main">
               <a:ext uri="{FF2B5EF4-FFF2-40B4-BE49-F238E27FC236}">
-                <a16:creationId xmlns:a16="http://schemas.microsoft.com/office/drawing/2014/main" id="{4D0CBE4D-002D-4B12-B770-E32F32985BF4}"/>
+                <a16:creationId xmlns:a16="http://schemas.microsoft.com/office/drawing/2014/main" id="{6F5275D9-E64A-40AC-AF63-70D44D2D2F18}"/>
               </a:ext>
             </a:extLst>
           </p:cNvPr>
@@ -4175,7 +4856,7 @@
           <p:cNvPr id="3" name="">
             <a:extLst xmlns:a="http://schemas.openxmlformats.org/drawingml/2006/main">
               <a:ext uri="{FF2B5EF4-FFF2-40B4-BE49-F238E27FC236}">
-                <a16:creationId xmlns:a16="http://schemas.microsoft.com/office/drawing/2014/main" id="{11718BAC-285C-44DE-978D-EE942BA08044}"/>
+                <a16:creationId xmlns:a16="http://schemas.microsoft.com/office/drawing/2014/main" id="{B964B23C-E87C-4C5A-A797-A7EECDD0190C}"/>
               </a:ext>
             </a:extLst>
           </p:cNvPr>
@@ -4232,7 +4913,7 @@
           <p:cNvPr id="4" name="">
             <a:extLst xmlns:a="http://schemas.openxmlformats.org/drawingml/2006/main">
               <a:ext uri="{FF2B5EF4-FFF2-40B4-BE49-F238E27FC236}">
-                <a16:creationId xmlns:a16="http://schemas.microsoft.com/office/drawing/2014/main" id="{7E26EFAD-E896-4D64-8B81-8A8645C427C9}"/>
+                <a16:creationId xmlns:a16="http://schemas.microsoft.com/office/drawing/2014/main" id="{45440E6F-998C-44FD-975D-2150B5112913}"/>
               </a:ext>
             </a:extLst>
           </p:cNvPr>
@@ -4289,7 +4970,7 @@
           <p:cNvPr id="5" name="">
             <a:extLst xmlns:a="http://schemas.openxmlformats.org/drawingml/2006/main">
               <a:ext uri="{FF2B5EF4-FFF2-40B4-BE49-F238E27FC236}">
-                <a16:creationId xmlns:a16="http://schemas.microsoft.com/office/drawing/2014/main" id="{90A7E51D-4653-45F2-9C66-6A4AED86920D}"/>
+                <a16:creationId xmlns:a16="http://schemas.microsoft.com/office/drawing/2014/main" id="{19CA92A9-991A-4238-AC4B-D026E6B21F8F}"/>
               </a:ext>
             </a:extLst>
           </p:cNvPr>
@@ -4344,7 +5025,7 @@
     </p:spTree>
     <p:extLst>
       <p:ext uri="{BB962C8B-B14F-4D97-AF65-F5344CB8AC3E}">
-        <p14:creationId xmlns:p14="http://schemas.microsoft.com/office/powerpoint/2010/main" val="567009666"/>
+        <p14:creationId xmlns:p14="http://schemas.microsoft.com/office/powerpoint/2010/main" val="1093192275"/>
       </p:ext>
     </p:extLst>
   </p:cSld>
@@ -4375,7 +5056,7 @@
           <p:cNvPr id="7" name="">
             <a:extLst xmlns:a="http://schemas.openxmlformats.org/drawingml/2006/main">
               <a:ext uri="{FF2B5EF4-FFF2-40B4-BE49-F238E27FC236}">
-                <a16:creationId xmlns:a16="http://schemas.microsoft.com/office/drawing/2014/main" id="{9C6D3BF6-1A82-4AD5-B12A-D422F7D964C4}"/>
+                <a16:creationId xmlns:a16="http://schemas.microsoft.com/office/drawing/2014/main" id="{4124D612-8520-40A2-A844-6F18B8F49070}"/>
               </a:ext>
             </a:extLst>
           </p:cNvPr>
@@ -4432,7 +5113,7 @@
           <p:cNvPr id="2" name="">
             <a:extLst xmlns:a="http://schemas.openxmlformats.org/drawingml/2006/main">
               <a:ext uri="{FF2B5EF4-FFF2-40B4-BE49-F238E27FC236}">
-                <a16:creationId xmlns:a16="http://schemas.microsoft.com/office/drawing/2014/main" id="{63BCA673-7ECA-4539-B6F9-F77BBAD80B9A}"/>
+                <a16:creationId xmlns:a16="http://schemas.microsoft.com/office/drawing/2014/main" id="{B05246CF-3916-4BE5-A574-AE3E3F8993E6}"/>
               </a:ext>
             </a:extLst>
           </p:cNvPr>
@@ -4489,7 +5170,7 @@
           <p:cNvPr id="3" name="">
             <a:extLst xmlns:a="http://schemas.openxmlformats.org/drawingml/2006/main">
               <a:ext uri="{FF2B5EF4-FFF2-40B4-BE49-F238E27FC236}">
-                <a16:creationId xmlns:a16="http://schemas.microsoft.com/office/drawing/2014/main" id="{451CC8AE-BF8E-4E55-A682-77777B1F9501}"/>
+                <a16:creationId xmlns:a16="http://schemas.microsoft.com/office/drawing/2014/main" id="{8ECE35A1-5AC2-439F-92B3-198919C4C117}"/>
               </a:ext>
             </a:extLst>
           </p:cNvPr>
@@ -4546,7 +5227,7 @@
           <p:cNvPr id="4" name="">
             <a:extLst xmlns:a="http://schemas.openxmlformats.org/drawingml/2006/main">
               <a:ext uri="{FF2B5EF4-FFF2-40B4-BE49-F238E27FC236}">
-                <a16:creationId xmlns:a16="http://schemas.microsoft.com/office/drawing/2014/main" id="{B1693917-C2F5-41AD-A2F0-0D9C38815301}"/>
+                <a16:creationId xmlns:a16="http://schemas.microsoft.com/office/drawing/2014/main" id="{75F25252-BC94-48C3-B1A4-04116160DF5A}"/>
               </a:ext>
             </a:extLst>
           </p:cNvPr>
@@ -4603,7 +5284,7 @@
           <p:cNvPr id="5" name="">
             <a:extLst xmlns:a="http://schemas.openxmlformats.org/drawingml/2006/main">
               <a:ext uri="{FF2B5EF4-FFF2-40B4-BE49-F238E27FC236}">
-                <a16:creationId xmlns:a16="http://schemas.microsoft.com/office/drawing/2014/main" id="{12304B9C-4759-41DA-BBE7-21F292894CF5}"/>
+                <a16:creationId xmlns:a16="http://schemas.microsoft.com/office/drawing/2014/main" id="{3A121551-C967-46BC-B824-C10ECDACF891}"/>
               </a:ext>
             </a:extLst>
           </p:cNvPr>
@@ -4660,7 +5341,7 @@
           <p:cNvPr id="6" name="">
             <a:extLst xmlns:a="http://schemas.openxmlformats.org/drawingml/2006/main">
               <a:ext uri="{FF2B5EF4-FFF2-40B4-BE49-F238E27FC236}">
-                <a16:creationId xmlns:a16="http://schemas.microsoft.com/office/drawing/2014/main" id="{C8848B10-B08F-4B97-A2E3-E293F13A7C21}"/>
+                <a16:creationId xmlns:a16="http://schemas.microsoft.com/office/drawing/2014/main" id="{47AD9A02-B9A9-4C09-B0E4-CA20B53E0670}"/>
               </a:ext>
             </a:extLst>
           </p:cNvPr>
@@ -4715,7 +5396,7 @@
     </p:spTree>
     <p:extLst>
       <p:ext uri="{BB962C8B-B14F-4D97-AF65-F5344CB8AC3E}">
-        <p14:creationId xmlns:p14="http://schemas.microsoft.com/office/powerpoint/2010/main" val="880440990"/>
+        <p14:creationId xmlns:p14="http://schemas.microsoft.com/office/powerpoint/2010/main" val="1324861580"/>
       </p:ext>
     </p:extLst>
   </p:cSld>
@@ -4746,7 +5427,7 @@
           <p:cNvPr id="4" name="">
             <a:extLst xmlns:a="http://schemas.openxmlformats.org/drawingml/2006/main">
               <a:ext uri="{FF2B5EF4-FFF2-40B4-BE49-F238E27FC236}">
-                <a16:creationId xmlns:a16="http://schemas.microsoft.com/office/drawing/2014/main" id="{EC6B4F42-63C9-4103-9218-494433FE50B2}"/>
+                <a16:creationId xmlns:a16="http://schemas.microsoft.com/office/drawing/2014/main" id="{4AA64889-F46B-4330-9944-73F64D29A6DE}"/>
               </a:ext>
             </a:extLst>
           </p:cNvPr>
@@ -5270,7 +5951,7 @@
           <p:cNvPr id="3" name="">
             <a:extLst xmlns:a="http://schemas.openxmlformats.org/drawingml/2006/main">
               <a:ext uri="{FF2B5EF4-FFF2-40B4-BE49-F238E27FC236}">
-                <a16:creationId xmlns:a16="http://schemas.microsoft.com/office/drawing/2014/main" id="{3A5E2980-8C53-4EC6-8991-7FF5CC068861}"/>
+                <a16:creationId xmlns:a16="http://schemas.microsoft.com/office/drawing/2014/main" id="{F4AB234F-8048-449F-8019-6B7834E3D961}"/>
               </a:ext>
             </a:extLst>
           </p:cNvPr>
@@ -5325,7 +6006,7 @@
     </p:spTree>
     <p:extLst>
       <p:ext uri="{BB962C8B-B14F-4D97-AF65-F5344CB8AC3E}">
-        <p14:creationId xmlns:p14="http://schemas.microsoft.com/office/powerpoint/2010/main" val="130564132"/>
+        <p14:creationId xmlns:p14="http://schemas.microsoft.com/office/powerpoint/2010/main" val="886922101"/>
       </p:ext>
     </p:extLst>
   </p:cSld>
@@ -5356,7 +6037,7 @@
           <p:cNvPr id="8" name="">
             <a:extLst xmlns:a="http://schemas.openxmlformats.org/drawingml/2006/main">
               <a:ext uri="{FF2B5EF4-FFF2-40B4-BE49-F238E27FC236}">
-                <a16:creationId xmlns:a16="http://schemas.microsoft.com/office/drawing/2014/main" id="{859CB322-6059-4252-AFE5-6F1FA9B082E7}"/>
+                <a16:creationId xmlns:a16="http://schemas.microsoft.com/office/drawing/2014/main" id="{E3A39114-6169-405E-8FF9-4253E822A1FD}"/>
               </a:ext>
             </a:extLst>
           </p:cNvPr>
@@ -5413,7 +6094,7 @@
           <p:cNvPr id="2" name="">
             <a:extLst xmlns:a="http://schemas.openxmlformats.org/drawingml/2006/main">
               <a:ext uri="{FF2B5EF4-FFF2-40B4-BE49-F238E27FC236}">
-                <a16:creationId xmlns:a16="http://schemas.microsoft.com/office/drawing/2014/main" id="{4C4E613C-6321-4744-8878-F957226CDC3A}"/>
+                <a16:creationId xmlns:a16="http://schemas.microsoft.com/office/drawing/2014/main" id="{733A5AF7-23E4-45BC-8133-A2F7434DBB6B}"/>
               </a:ext>
             </a:extLst>
           </p:cNvPr>
@@ -5470,7 +6151,7 @@
           <p:cNvPr id="3" name="">
             <a:extLst xmlns:a="http://schemas.openxmlformats.org/drawingml/2006/main">
               <a:ext uri="{FF2B5EF4-FFF2-40B4-BE49-F238E27FC236}">
-                <a16:creationId xmlns:a16="http://schemas.microsoft.com/office/drawing/2014/main" id="{86FCEE9E-48A8-4A65-A853-22B33184FA07}"/>
+                <a16:creationId xmlns:a16="http://schemas.microsoft.com/office/drawing/2014/main" id="{2D4EADB6-AE8C-4FB9-868E-520A5CE4B5C3}"/>
               </a:ext>
             </a:extLst>
           </p:cNvPr>
@@ -5527,7 +6208,7 @@
           <p:cNvPr id="4" name="">
             <a:extLst xmlns:a="http://schemas.openxmlformats.org/drawingml/2006/main">
               <a:ext uri="{FF2B5EF4-FFF2-40B4-BE49-F238E27FC236}">
-                <a16:creationId xmlns:a16="http://schemas.microsoft.com/office/drawing/2014/main" id="{0825947A-6CA1-490B-8103-0BB42ED72659}"/>
+                <a16:creationId xmlns:a16="http://schemas.microsoft.com/office/drawing/2014/main" id="{9C4AEF4C-B081-492F-97AF-C17B1ED4897B}"/>
               </a:ext>
             </a:extLst>
           </p:cNvPr>
@@ -5574,7 +6255,7 @@
                 <a:ea typeface="Arial"/>
                 <a:cs typeface="Arial"/>
               </a:rPr>
-              <a:t>Excitation travels with spin up; the ground state carries spin down.</a:t>
+              <a:t>The excited level is paired with spin up; the ground level with spin down.</a:t>
             </a:r>
           </a:p>
         </p:txBody>
@@ -5584,7 +6265,7 @@
           <p:cNvPr id="5" name="">
             <a:extLst xmlns:a="http://schemas.openxmlformats.org/drawingml/2006/main">
               <a:ext uri="{FF2B5EF4-FFF2-40B4-BE49-F238E27FC236}">
-                <a16:creationId xmlns:a16="http://schemas.microsoft.com/office/drawing/2014/main" id="{9731AD5A-3E80-47FA-8A03-A6C5844CB15E}"/>
+                <a16:creationId xmlns:a16="http://schemas.microsoft.com/office/drawing/2014/main" id="{0EED233D-E83F-47B5-BECE-9EA94D7D229E}"/>
               </a:ext>
             </a:extLst>
           </p:cNvPr>
@@ -5641,7 +6322,7 @@
           <p:cNvPr id="6" name="">
             <a:extLst xmlns:a="http://schemas.openxmlformats.org/drawingml/2006/main">
               <a:ext uri="{FF2B5EF4-FFF2-40B4-BE49-F238E27FC236}">
-                <a16:creationId xmlns:a16="http://schemas.microsoft.com/office/drawing/2014/main" id="{9868C4E8-AA1B-46DB-BA2E-A1BC50DA324E}"/>
+                <a16:creationId xmlns:a16="http://schemas.microsoft.com/office/drawing/2014/main" id="{C6FA6AA4-A497-4A4E-9F0A-2D14397F54F7}"/>
               </a:ext>
             </a:extLst>
           </p:cNvPr>
@@ -5688,7 +6369,7 @@
                 <a:ea typeface="Arial"/>
                 <a:cs typeface="Arial"/>
               </a:rPr>
-              <a:t>Excitation travels with spin down; the ground state carries spin up.</a:t>
+              <a:t>The excited level is paired with spin down; the ground level with spin up.</a:t>
             </a:r>
           </a:p>
         </p:txBody>
@@ -5698,7 +6379,7 @@
           <p:cNvPr id="7" name="">
             <a:extLst xmlns:a="http://schemas.openxmlformats.org/drawingml/2006/main">
               <a:ext uri="{FF2B5EF4-FFF2-40B4-BE49-F238E27FC236}">
-                <a16:creationId xmlns:a16="http://schemas.microsoft.com/office/drawing/2014/main" id="{C7FA6FD2-CE4D-4ED4-99BC-5E215A3151FD}"/>
+                <a16:creationId xmlns:a16="http://schemas.microsoft.com/office/drawing/2014/main" id="{8D3EC445-FA59-476F-B650-FA5FE334038D}"/>
               </a:ext>
             </a:extLst>
           </p:cNvPr>
@@ -5753,7 +6434,7 @@
     </p:spTree>
     <p:extLst>
       <p:ext uri="{BB962C8B-B14F-4D97-AF65-F5344CB8AC3E}">
-        <p14:creationId xmlns:p14="http://schemas.microsoft.com/office/powerpoint/2010/main" val="596575776"/>
+        <p14:creationId xmlns:p14="http://schemas.microsoft.com/office/powerpoint/2010/main" val="1599244362"/>
       </p:ext>
     </p:extLst>
   </p:cSld>
@@ -5784,7 +6465,7 @@
           <p:cNvPr id="5" name="">
             <a:extLst xmlns:a="http://schemas.openxmlformats.org/drawingml/2006/main">
               <a:ext uri="{FF2B5EF4-FFF2-40B4-BE49-F238E27FC236}">
-                <a16:creationId xmlns:a16="http://schemas.microsoft.com/office/drawing/2014/main" id="{295B580A-3DB6-425D-95D2-A6A4C5A8F1B8}"/>
+                <a16:creationId xmlns:a16="http://schemas.microsoft.com/office/drawing/2014/main" id="{7D02A8B5-DC0A-4952-AE47-018637B0615B}"/>
               </a:ext>
             </a:extLst>
           </p:cNvPr>
@@ -5841,7 +6522,7 @@
           <p:cNvPr id="2" name="">
             <a:extLst xmlns:a="http://schemas.openxmlformats.org/drawingml/2006/main">
               <a:ext uri="{FF2B5EF4-FFF2-40B4-BE49-F238E27FC236}">
-                <a16:creationId xmlns:a16="http://schemas.microsoft.com/office/drawing/2014/main" id="{E8B9663D-361B-4E82-A86A-5AA6EC5AF219}"/>
+                <a16:creationId xmlns:a16="http://schemas.microsoft.com/office/drawing/2014/main" id="{3518356A-E920-48F4-85DA-56405BC7C2F1}"/>
               </a:ext>
             </a:extLst>
           </p:cNvPr>
@@ -5898,7 +6579,7 @@
           <p:cNvPr id="3" name="">
             <a:extLst xmlns:a="http://schemas.openxmlformats.org/drawingml/2006/main">
               <a:ext uri="{FF2B5EF4-FFF2-40B4-BE49-F238E27FC236}">
-                <a16:creationId xmlns:a16="http://schemas.microsoft.com/office/drawing/2014/main" id="{8DE36559-3A8D-432D-99CA-981D445BD286}"/>
+                <a16:creationId xmlns:a16="http://schemas.microsoft.com/office/drawing/2014/main" id="{D174EF53-C982-4E08-81D8-72107649DE5A}"/>
               </a:ext>
             </a:extLst>
           </p:cNvPr>
@@ -5955,7 +6636,7 @@
           <p:cNvPr id="4" name="">
             <a:extLst xmlns:a="http://schemas.openxmlformats.org/drawingml/2006/main">
               <a:ext uri="{FF2B5EF4-FFF2-40B4-BE49-F238E27FC236}">
-                <a16:creationId xmlns:a16="http://schemas.microsoft.com/office/drawing/2014/main" id="{7E4A1A97-3618-466F-B3FB-EEB6ABD59852}"/>
+                <a16:creationId xmlns:a16="http://schemas.microsoft.com/office/drawing/2014/main" id="{E0ECDE36-51A3-4D86-A287-8BBF5EC36B83}"/>
               </a:ext>
             </a:extLst>
           </p:cNvPr>
@@ -6002,7 +6683,7 @@
                 <a:ea typeface="Arial"/>
                 <a:cs typeface="Arial"/>
               </a:rPr>
-              <a:t>The alternative with the excitation higher in the building evolves relative to the alternative with the excitation lower down. Spectroscopy fixes ΔE. An independent potential survey fixes the predicted Δτ.</a:t>
+              <a:t>The alternative with the excitation higher in the building evolves relative to the alternative with the excitation lower down. Spectroscopy fixes ΔE. An independent potential survey and interrogation time fix the predicted Δτ.</a:t>
             </a:r>
           </a:p>
         </p:txBody>
@@ -6010,7 +6691,7 @@
     </p:spTree>
     <p:extLst>
       <p:ext uri="{BB962C8B-B14F-4D97-AF65-F5344CB8AC3E}">
-        <p14:creationId xmlns:p14="http://schemas.microsoft.com/office/powerpoint/2010/main" val="2118626227"/>
+        <p14:creationId xmlns:p14="http://schemas.microsoft.com/office/powerpoint/2010/main" val="2108036139"/>
       </p:ext>
     </p:extLst>
   </p:cSld>
@@ -6041,7 +6722,7 @@
           <p:cNvPr id="5" name="">
             <a:extLst xmlns:a="http://schemas.openxmlformats.org/drawingml/2006/main">
               <a:ext uri="{FF2B5EF4-FFF2-40B4-BE49-F238E27FC236}">
-                <a16:creationId xmlns:a16="http://schemas.microsoft.com/office/drawing/2014/main" id="{CBB2AD3C-4A06-44C6-957B-8C015342540B}"/>
+                <a16:creationId xmlns:a16="http://schemas.microsoft.com/office/drawing/2014/main" id="{6FC62DBD-299C-477A-980F-9491872D74FF}"/>
               </a:ext>
             </a:extLst>
           </p:cNvPr>
@@ -6098,7 +6779,7 @@
           <p:cNvPr id="2" name="">
             <a:extLst xmlns:a="http://schemas.openxmlformats.org/drawingml/2006/main">
               <a:ext uri="{FF2B5EF4-FFF2-40B4-BE49-F238E27FC236}">
-                <a16:creationId xmlns:a16="http://schemas.microsoft.com/office/drawing/2014/main" id="{E4481EFF-60B1-4C2E-86A1-055562C34814}"/>
+                <a16:creationId xmlns:a16="http://schemas.microsoft.com/office/drawing/2014/main" id="{2BC83718-996E-4328-AD70-680E21C9B967}"/>
               </a:ext>
             </a:extLst>
           </p:cNvPr>
@@ -6155,7 +6836,7 @@
           <p:cNvPr id="3" name="">
             <a:extLst xmlns:a="http://schemas.openxmlformats.org/drawingml/2006/main">
               <a:ext uri="{FF2B5EF4-FFF2-40B4-BE49-F238E27FC236}">
-                <a16:creationId xmlns:a16="http://schemas.microsoft.com/office/drawing/2014/main" id="{912B41CD-12CB-4849-AD2B-802B15D34BB5}"/>
+                <a16:creationId xmlns:a16="http://schemas.microsoft.com/office/drawing/2014/main" id="{82327962-2627-44A6-8E4A-F31EF20A192F}"/>
               </a:ext>
             </a:extLst>
           </p:cNvPr>
@@ -6212,7 +6893,7 @@
           <p:cNvPr id="4" name="">
             <a:extLst xmlns:a="http://schemas.openxmlformats.org/drawingml/2006/main">
               <a:ext uri="{FF2B5EF4-FFF2-40B4-BE49-F238E27FC236}">
-                <a16:creationId xmlns:a16="http://schemas.microsoft.com/office/drawing/2014/main" id="{F9234BF1-DC3E-4EBF-8DCB-0A805F4C683C}"/>
+                <a16:creationId xmlns:a16="http://schemas.microsoft.com/office/drawing/2014/main" id="{03B2CB41-469A-4341-B17E-861D0876639A}"/>
               </a:ext>
             </a:extLst>
           </p:cNvPr>
@@ -6267,7 +6948,7 @@
     </p:spTree>
     <p:extLst>
       <p:ext uri="{BB962C8B-B14F-4D97-AF65-F5344CB8AC3E}">
-        <p14:creationId xmlns:p14="http://schemas.microsoft.com/office/powerpoint/2010/main" val="1214855978"/>
+        <p14:creationId xmlns:p14="http://schemas.microsoft.com/office/powerpoint/2010/main" val="607689485"/>
       </p:ext>
     </p:extLst>
   </p:cSld>

</xml_diff>

<commit_message>
docs(theory): refresh proposal build artifacts
</commit_message>
<xml_diff>
--- a/.codex-build/ytterbium-clock-proposal/candidate.pptx
+++ b/.codex-build/ytterbium-clock-proposal/candidate.pptx
@@ -2,26 +2,26 @@
 <file path=ppt/presentation.xml><?xml version="1.0" encoding="utf-8"?>
 <p:presentation xmlns:p="http://schemas.openxmlformats.org/presentationml/2006/main">
   <p:sldMasterIdLst>
-    <p:sldMasterId xmlns:r="http://schemas.openxmlformats.org/officeDocument/2006/relationships" id="2147483648" r:id="R73fb64b0db9d4e62"/>
+    <p:sldMasterId xmlns:r="http://schemas.openxmlformats.org/officeDocument/2006/relationships" id="2147483648" r:id="R52cffb03065d4584"/>
   </p:sldMasterIdLst>
   <p:notesMasterIdLst>
-    <p:notesMasterId xmlns:r="http://schemas.openxmlformats.org/officeDocument/2006/relationships" r:id="R84cfc08b067b4d53"/>
+    <p:notesMasterId xmlns:r="http://schemas.openxmlformats.org/officeDocument/2006/relationships" r:id="R20a6f81abf364979"/>
   </p:notesMasterIdLst>
   <p:sldIdLst>
-    <p:sldId xmlns:r="http://schemas.openxmlformats.org/officeDocument/2006/relationships" id="256" r:id="R07c6eba1515443d1"/>
-    <p:sldId xmlns:r="http://schemas.openxmlformats.org/officeDocument/2006/relationships" id="257" r:id="R51e69329807d4685"/>
-    <p:sldId xmlns:r="http://schemas.openxmlformats.org/officeDocument/2006/relationships" id="258" r:id="R0ee0b61db1004cc4"/>
-    <p:sldId xmlns:r="http://schemas.openxmlformats.org/officeDocument/2006/relationships" id="259" r:id="R6045021c47774b4d"/>
-    <p:sldId xmlns:r="http://schemas.openxmlformats.org/officeDocument/2006/relationships" id="260" r:id="R0ca6e79dbb404a37"/>
-    <p:sldId xmlns:r="http://schemas.openxmlformats.org/officeDocument/2006/relationships" id="261" r:id="R797944ae9acb4fa1"/>
-    <p:sldId xmlns:r="http://schemas.openxmlformats.org/officeDocument/2006/relationships" id="262" r:id="Rac8a50ea8e464c83"/>
-    <p:sldId xmlns:r="http://schemas.openxmlformats.org/officeDocument/2006/relationships" id="263" r:id="R766d4c3de8f74c42"/>
-    <p:sldId xmlns:r="http://schemas.openxmlformats.org/officeDocument/2006/relationships" id="264" r:id="R387c74bcf8ba4efc"/>
-    <p:sldId xmlns:r="http://schemas.openxmlformats.org/officeDocument/2006/relationships" id="265" r:id="R2270b18b76f1414f"/>
-    <p:sldId xmlns:r="http://schemas.openxmlformats.org/officeDocument/2006/relationships" id="266" r:id="R6955489c168c4146"/>
-    <p:sldId xmlns:r="http://schemas.openxmlformats.org/officeDocument/2006/relationships" id="267" r:id="Rd694d89f07164b0f"/>
-    <p:sldId xmlns:r="http://schemas.openxmlformats.org/officeDocument/2006/relationships" id="268" r:id="R5b514ba33a7a4914"/>
-    <p:sldId xmlns:r="http://schemas.openxmlformats.org/officeDocument/2006/relationships" id="269" r:id="Rba16e5e0b59b48d8"/>
+    <p:sldId xmlns:r="http://schemas.openxmlformats.org/officeDocument/2006/relationships" id="256" r:id="R98690e0e5b164856"/>
+    <p:sldId xmlns:r="http://schemas.openxmlformats.org/officeDocument/2006/relationships" id="257" r:id="R6ee31e0404d84bd7"/>
+    <p:sldId xmlns:r="http://schemas.openxmlformats.org/officeDocument/2006/relationships" id="258" r:id="R790f5bbd17084a22"/>
+    <p:sldId xmlns:r="http://schemas.openxmlformats.org/officeDocument/2006/relationships" id="259" r:id="R6ee3b3efd6ab45a2"/>
+    <p:sldId xmlns:r="http://schemas.openxmlformats.org/officeDocument/2006/relationships" id="260" r:id="R90181a156bad43fb"/>
+    <p:sldId xmlns:r="http://schemas.openxmlformats.org/officeDocument/2006/relationships" id="261" r:id="R79c474b0f7264895"/>
+    <p:sldId xmlns:r="http://schemas.openxmlformats.org/officeDocument/2006/relationships" id="262" r:id="R99fd42047b5d4800"/>
+    <p:sldId xmlns:r="http://schemas.openxmlformats.org/officeDocument/2006/relationships" id="263" r:id="R82b7334eaae44a26"/>
+    <p:sldId xmlns:r="http://schemas.openxmlformats.org/officeDocument/2006/relationships" id="264" r:id="R242474cafa044e3c"/>
+    <p:sldId xmlns:r="http://schemas.openxmlformats.org/officeDocument/2006/relationships" id="265" r:id="R7f00b4921fc5477b"/>
+    <p:sldId xmlns:r="http://schemas.openxmlformats.org/officeDocument/2006/relationships" id="266" r:id="R3e78b206fc5f4e2d"/>
+    <p:sldId xmlns:r="http://schemas.openxmlformats.org/officeDocument/2006/relationships" id="267" r:id="R52a9ecfc4d374a26"/>
+    <p:sldId xmlns:r="http://schemas.openxmlformats.org/officeDocument/2006/relationships" id="268" r:id="R4cb93e13a7ca4f43"/>
+    <p:sldId xmlns:r="http://schemas.openxmlformats.org/officeDocument/2006/relationships" id="269" r:id="R8176c7f4df3a4c77"/>
   </p:sldIdLst>
   <p:sldSz cx="12192000" cy="6858000"/>
   <p:notesSz cx="6858000" cy="9144000"/>
@@ -1563,7 +1563,7 @@
   </p:cSld>
   <p:clrMap bg1="lt1" tx1="dk1" bg2="lt2" tx2="dk2" accent1="accent1" accent2="accent2" accent3="accent3" accent4="accent4" accent5="accent5" accent6="accent6" hlink="hlink" folHlink="folHlink"/>
   <p:sldLayoutIdLst>
-    <p:sldLayoutId xmlns:r="http://schemas.openxmlformats.org/officeDocument/2006/relationships" id="2147483649" r:id="Rfc7196e6b5c44dcc"/>
+    <p:sldLayoutId xmlns:r="http://schemas.openxmlformats.org/officeDocument/2006/relationships" id="2147483649" r:id="R124f39b0a83546b2"/>
   </p:sldLayoutIdLst>
   <p:txStyles>
     <p:titleStyle>
@@ -2118,7 +2118,7 @@
           <p:nvPr/>
         </p:nvPicPr>
         <p:blipFill>
-          <a:blip xmlns:r="http://schemas.openxmlformats.org/officeDocument/2006/relationships" xmlns:a="http://schemas.openxmlformats.org/drawingml/2006/main" r:embed="R417d4a3b35724688"/>
+          <a:blip xmlns:r="http://schemas.openxmlformats.org/officeDocument/2006/relationships" xmlns:a="http://schemas.openxmlformats.org/drawingml/2006/main" r:embed="R6fe9616f19b04464"/>
           <a:srcRect xmlns:a="http://schemas.openxmlformats.org/drawingml/2006/main" l="0" t="27" r="0" b="27"/>
           <a:stretch xmlns:a="http://schemas.openxmlformats.org/drawingml/2006/main">
             <a:fillRect l="0" t="0" r="0" b="0"/>
@@ -2139,7 +2139,7 @@
           <p:cNvPr id="2" name="">
             <a:extLst xmlns:a="http://schemas.openxmlformats.org/drawingml/2006/main">
               <a:ext uri="{FF2B5EF4-FFF2-40B4-BE49-F238E27FC236}">
-                <a16:creationId xmlns:a16="http://schemas.microsoft.com/office/drawing/2014/main" id="{871D205E-284E-4712-8588-12C412E5A56B}"/>
+                <a16:creationId xmlns:a16="http://schemas.microsoft.com/office/drawing/2014/main" id="{EA8522E3-1E22-4136-A128-F4C8813518EE}"/>
               </a:ext>
             </a:extLst>
           </p:cNvPr>
@@ -2219,7 +2219,7 @@
           <p:cNvPr id="3" name="">
             <a:extLst xmlns:a="http://schemas.openxmlformats.org/drawingml/2006/main">
               <a:ext uri="{FF2B5EF4-FFF2-40B4-BE49-F238E27FC236}">
-                <a16:creationId xmlns:a16="http://schemas.microsoft.com/office/drawing/2014/main" id="{E691EA70-F794-4571-ADEA-EC8386571C8A}"/>
+                <a16:creationId xmlns:a16="http://schemas.microsoft.com/office/drawing/2014/main" id="{E20914B8-02A3-4A1E-B879-A91B4ED6A333}"/>
               </a:ext>
             </a:extLst>
           </p:cNvPr>
@@ -2274,7 +2274,7 @@
     </p:spTree>
     <p:extLst>
       <p:ext uri="{BB962C8B-B14F-4D97-AF65-F5344CB8AC3E}">
-        <p14:creationId xmlns:p14="http://schemas.microsoft.com/office/powerpoint/2010/main" val="936889475"/>
+        <p14:creationId xmlns:p14="http://schemas.microsoft.com/office/powerpoint/2010/main" val="1628060271"/>
       </p:ext>
     </p:extLst>
   </p:cSld>
@@ -2305,7 +2305,7 @@
           <p:cNvPr id="5" name="">
             <a:extLst xmlns:a="http://schemas.openxmlformats.org/drawingml/2006/main">
               <a:ext uri="{FF2B5EF4-FFF2-40B4-BE49-F238E27FC236}">
-                <a16:creationId xmlns:a16="http://schemas.microsoft.com/office/drawing/2014/main" id="{C92E2470-48EE-47DD-9A07-EB29520B6273}"/>
+                <a16:creationId xmlns:a16="http://schemas.microsoft.com/office/drawing/2014/main" id="{B05F8099-DBE2-4D62-A494-75AFA029C7D3}"/>
               </a:ext>
             </a:extLst>
           </p:cNvPr>
@@ -2362,7 +2362,7 @@
           <p:cNvPr id="2" name="">
             <a:extLst xmlns:a="http://schemas.openxmlformats.org/drawingml/2006/main">
               <a:ext uri="{FF2B5EF4-FFF2-40B4-BE49-F238E27FC236}">
-                <a16:creationId xmlns:a16="http://schemas.microsoft.com/office/drawing/2014/main" id="{69448C4D-BE6E-41E9-924A-ED9634DB9E4D}"/>
+                <a16:creationId xmlns:a16="http://schemas.microsoft.com/office/drawing/2014/main" id="{3D0A8D8F-9260-413F-87D4-85D5976D5DE9}"/>
               </a:ext>
             </a:extLst>
           </p:cNvPr>
@@ -2419,7 +2419,7 @@
           <p:cNvPr id="3" name="">
             <a:extLst xmlns:a="http://schemas.openxmlformats.org/drawingml/2006/main">
               <a:ext uri="{FF2B5EF4-FFF2-40B4-BE49-F238E27FC236}">
-                <a16:creationId xmlns:a16="http://schemas.microsoft.com/office/drawing/2014/main" id="{60874E09-C54D-4A14-9F84-D0678BFA179A}"/>
+                <a16:creationId xmlns:a16="http://schemas.microsoft.com/office/drawing/2014/main" id="{5C53FE65-8C0F-4665-A39D-E1457AB63311}"/>
               </a:ext>
             </a:extLst>
           </p:cNvPr>
@@ -2476,7 +2476,7 @@
           <p:cNvPr id="4" name="">
             <a:extLst xmlns:a="http://schemas.openxmlformats.org/drawingml/2006/main">
               <a:ext uri="{FF2B5EF4-FFF2-40B4-BE49-F238E27FC236}">
-                <a16:creationId xmlns:a16="http://schemas.microsoft.com/office/drawing/2014/main" id="{7C0D5C53-EA7C-4253-B9C3-4EA5EAE86028}"/>
+                <a16:creationId xmlns:a16="http://schemas.microsoft.com/office/drawing/2014/main" id="{0D7C28F6-FF5B-413F-8620-EFECF6924C83}"/>
               </a:ext>
             </a:extLst>
           </p:cNvPr>
@@ -2531,7 +2531,7 @@
     </p:spTree>
     <p:extLst>
       <p:ext uri="{BB962C8B-B14F-4D97-AF65-F5344CB8AC3E}">
-        <p14:creationId xmlns:p14="http://schemas.microsoft.com/office/powerpoint/2010/main" val="256150957"/>
+        <p14:creationId xmlns:p14="http://schemas.microsoft.com/office/powerpoint/2010/main" val="821457017"/>
       </p:ext>
     </p:extLst>
   </p:cSld>
@@ -2562,7 +2562,7 @@
           <p:cNvPr id="5" name="">
             <a:extLst xmlns:a="http://schemas.openxmlformats.org/drawingml/2006/main">
               <a:ext uri="{FF2B5EF4-FFF2-40B4-BE49-F238E27FC236}">
-                <a16:creationId xmlns:a16="http://schemas.microsoft.com/office/drawing/2014/main" id="{0F0D49CC-D82E-4460-97A0-5316001F0584}"/>
+                <a16:creationId xmlns:a16="http://schemas.microsoft.com/office/drawing/2014/main" id="{5AAFE29D-03F3-4859-83A1-AD2088BCA4C9}"/>
               </a:ext>
             </a:extLst>
           </p:cNvPr>
@@ -2619,7 +2619,7 @@
           <p:cNvPr id="2" name="">
             <a:extLst xmlns:a="http://schemas.openxmlformats.org/drawingml/2006/main">
               <a:ext uri="{FF2B5EF4-FFF2-40B4-BE49-F238E27FC236}">
-                <a16:creationId xmlns:a16="http://schemas.microsoft.com/office/drawing/2014/main" id="{016876CA-BA2F-4E7C-BD4A-B794798F30D4}"/>
+                <a16:creationId xmlns:a16="http://schemas.microsoft.com/office/drawing/2014/main" id="{D394C465-34DA-48B1-985A-AFA451CAC7DD}"/>
               </a:ext>
             </a:extLst>
           </p:cNvPr>
@@ -2676,7 +2676,7 @@
           <p:cNvPr id="3" name="">
             <a:extLst xmlns:a="http://schemas.openxmlformats.org/drawingml/2006/main">
               <a:ext uri="{FF2B5EF4-FFF2-40B4-BE49-F238E27FC236}">
-                <a16:creationId xmlns:a16="http://schemas.microsoft.com/office/drawing/2014/main" id="{ED14D69E-9BDE-4E79-8DA6-5CF16BCCB6FF}"/>
+                <a16:creationId xmlns:a16="http://schemas.microsoft.com/office/drawing/2014/main" id="{082ADD33-447B-4999-829B-7005FD5EA744}"/>
               </a:ext>
             </a:extLst>
           </p:cNvPr>
@@ -2733,7 +2733,7 @@
           <p:cNvPr id="4" name="">
             <a:extLst xmlns:a="http://schemas.openxmlformats.org/drawingml/2006/main">
               <a:ext uri="{FF2B5EF4-FFF2-40B4-BE49-F238E27FC236}">
-                <a16:creationId xmlns:a16="http://schemas.microsoft.com/office/drawing/2014/main" id="{8DC63079-897E-49B2-B3AC-5C588F9E15C5}"/>
+                <a16:creationId xmlns:a16="http://schemas.microsoft.com/office/drawing/2014/main" id="{3BC7B594-9099-4DBF-A918-E85DE9A4344C}"/>
               </a:ext>
             </a:extLst>
           </p:cNvPr>
@@ -2788,7 +2788,7 @@
     </p:spTree>
     <p:extLst>
       <p:ext uri="{BB962C8B-B14F-4D97-AF65-F5344CB8AC3E}">
-        <p14:creationId xmlns:p14="http://schemas.microsoft.com/office/powerpoint/2010/main" val="1658383762"/>
+        <p14:creationId xmlns:p14="http://schemas.microsoft.com/office/powerpoint/2010/main" val="212359575"/>
       </p:ext>
     </p:extLst>
   </p:cSld>
@@ -2819,7 +2819,7 @@
           <p:cNvPr id="9" name="">
             <a:extLst xmlns:a="http://schemas.openxmlformats.org/drawingml/2006/main">
               <a:ext uri="{FF2B5EF4-FFF2-40B4-BE49-F238E27FC236}">
-                <a16:creationId xmlns:a16="http://schemas.microsoft.com/office/drawing/2014/main" id="{B1A55F82-21BF-42C8-91C7-317855F8EFAA}"/>
+                <a16:creationId xmlns:a16="http://schemas.microsoft.com/office/drawing/2014/main" id="{6C7AC03F-40CB-4512-951B-DEBB941EB0D2}"/>
               </a:ext>
             </a:extLst>
           </p:cNvPr>
@@ -2876,7 +2876,7 @@
           <p:cNvPr id="2" name="">
             <a:extLst xmlns:a="http://schemas.openxmlformats.org/drawingml/2006/main">
               <a:ext uri="{FF2B5EF4-FFF2-40B4-BE49-F238E27FC236}">
-                <a16:creationId xmlns:a16="http://schemas.microsoft.com/office/drawing/2014/main" id="{55A88A90-D0AD-4740-82A2-8A03AD7C1C9D}"/>
+                <a16:creationId xmlns:a16="http://schemas.microsoft.com/office/drawing/2014/main" id="{613B9AF6-EB97-4E13-8F47-038EFE3EAA0B}"/>
               </a:ext>
             </a:extLst>
           </p:cNvPr>
@@ -2933,7 +2933,7 @@
           <p:cNvPr id="3" name="">
             <a:extLst xmlns:a="http://schemas.openxmlformats.org/drawingml/2006/main">
               <a:ext uri="{FF2B5EF4-FFF2-40B4-BE49-F238E27FC236}">
-                <a16:creationId xmlns:a16="http://schemas.microsoft.com/office/drawing/2014/main" id="{9E075B79-0909-4244-B7E9-147E99BC3ABD}"/>
+                <a16:creationId xmlns:a16="http://schemas.microsoft.com/office/drawing/2014/main" id="{FF7D0E5F-C689-4582-B7F2-91297D2D1028}"/>
               </a:ext>
             </a:extLst>
           </p:cNvPr>
@@ -2990,7 +2990,7 @@
           <p:cNvPr id="4" name="">
             <a:extLst xmlns:a="http://schemas.openxmlformats.org/drawingml/2006/main">
               <a:ext uri="{FF2B5EF4-FFF2-40B4-BE49-F238E27FC236}">
-                <a16:creationId xmlns:a16="http://schemas.microsoft.com/office/drawing/2014/main" id="{A35ED381-455D-4681-B72A-9EFBBC49B939}"/>
+                <a16:creationId xmlns:a16="http://schemas.microsoft.com/office/drawing/2014/main" id="{E1839967-86F9-4D17-A021-388176661835}"/>
               </a:ext>
             </a:extLst>
           </p:cNvPr>
@@ -3047,7 +3047,7 @@
           <p:cNvPr id="5" name="">
             <a:extLst xmlns:a="http://schemas.openxmlformats.org/drawingml/2006/main">
               <a:ext uri="{FF2B5EF4-FFF2-40B4-BE49-F238E27FC236}">
-                <a16:creationId xmlns:a16="http://schemas.microsoft.com/office/drawing/2014/main" id="{037046D8-753F-49AF-8EFC-0B89E5800817}"/>
+                <a16:creationId xmlns:a16="http://schemas.microsoft.com/office/drawing/2014/main" id="{3A8C9EE8-2C0C-4D4F-8389-9DEE4A98E024}"/>
               </a:ext>
             </a:extLst>
           </p:cNvPr>
@@ -3104,7 +3104,7 @@
           <p:cNvPr id="6" name="">
             <a:extLst xmlns:a="http://schemas.openxmlformats.org/drawingml/2006/main">
               <a:ext uri="{FF2B5EF4-FFF2-40B4-BE49-F238E27FC236}">
-                <a16:creationId xmlns:a16="http://schemas.microsoft.com/office/drawing/2014/main" id="{CDEEBB56-3456-4337-92B8-555B7916A9C8}"/>
+                <a16:creationId xmlns:a16="http://schemas.microsoft.com/office/drawing/2014/main" id="{7B4568AA-10B3-4426-8958-CBDDDE116619}"/>
               </a:ext>
             </a:extLst>
           </p:cNvPr>
@@ -3161,7 +3161,7 @@
           <p:cNvPr id="7" name="">
             <a:extLst xmlns:a="http://schemas.openxmlformats.org/drawingml/2006/main">
               <a:ext uri="{FF2B5EF4-FFF2-40B4-BE49-F238E27FC236}">
-                <a16:creationId xmlns:a16="http://schemas.microsoft.com/office/drawing/2014/main" id="{603BE128-908D-4BD5-B203-DC946ECF16C9}"/>
+                <a16:creationId xmlns:a16="http://schemas.microsoft.com/office/drawing/2014/main" id="{95581FB9-56C6-4809-A36E-27C73E40162B}"/>
               </a:ext>
             </a:extLst>
           </p:cNvPr>
@@ -3218,7 +3218,7 @@
           <p:cNvPr id="8" name="">
             <a:extLst xmlns:a="http://schemas.openxmlformats.org/drawingml/2006/main">
               <a:ext uri="{FF2B5EF4-FFF2-40B4-BE49-F238E27FC236}">
-                <a16:creationId xmlns:a16="http://schemas.microsoft.com/office/drawing/2014/main" id="{FB024968-E596-437D-BA69-90D583FFA67A}"/>
+                <a16:creationId xmlns:a16="http://schemas.microsoft.com/office/drawing/2014/main" id="{54E9143C-E6F4-4FC9-B29D-D15AA90812EF}"/>
               </a:ext>
             </a:extLst>
           </p:cNvPr>
@@ -3273,7 +3273,7 @@
     </p:spTree>
     <p:extLst>
       <p:ext uri="{BB962C8B-B14F-4D97-AF65-F5344CB8AC3E}">
-        <p14:creationId xmlns:p14="http://schemas.microsoft.com/office/powerpoint/2010/main" val="785109382"/>
+        <p14:creationId xmlns:p14="http://schemas.microsoft.com/office/powerpoint/2010/main" val="1320666341"/>
       </p:ext>
     </p:extLst>
   </p:cSld>
@@ -3304,7 +3304,7 @@
           <p:cNvPr id="5" name="">
             <a:extLst xmlns:a="http://schemas.openxmlformats.org/drawingml/2006/main">
               <a:ext uri="{FF2B5EF4-FFF2-40B4-BE49-F238E27FC236}">
-                <a16:creationId xmlns:a16="http://schemas.microsoft.com/office/drawing/2014/main" id="{0806D558-FB8B-4E25-8445-A1D96DAD1055}"/>
+                <a16:creationId xmlns:a16="http://schemas.microsoft.com/office/drawing/2014/main" id="{AF79B331-7FB7-4813-AC79-F872CA7A126A}"/>
               </a:ext>
             </a:extLst>
           </p:cNvPr>
@@ -3361,7 +3361,7 @@
           <p:cNvPr id="2" name="">
             <a:extLst xmlns:a="http://schemas.openxmlformats.org/drawingml/2006/main">
               <a:ext uri="{FF2B5EF4-FFF2-40B4-BE49-F238E27FC236}">
-                <a16:creationId xmlns:a16="http://schemas.microsoft.com/office/drawing/2014/main" id="{64583986-7588-4C6F-AD36-3E8A32DA9E7C}"/>
+                <a16:creationId xmlns:a16="http://schemas.microsoft.com/office/drawing/2014/main" id="{1E2FCD5B-86AA-40EB-910D-D014602B795E}"/>
               </a:ext>
             </a:extLst>
           </p:cNvPr>
@@ -3418,7 +3418,7 @@
           <p:cNvPr id="3" name="">
             <a:extLst xmlns:a="http://schemas.openxmlformats.org/drawingml/2006/main">
               <a:ext uri="{FF2B5EF4-FFF2-40B4-BE49-F238E27FC236}">
-                <a16:creationId xmlns:a16="http://schemas.microsoft.com/office/drawing/2014/main" id="{865A1987-2975-48E4-8D97-B64F95C80627}"/>
+                <a16:creationId xmlns:a16="http://schemas.microsoft.com/office/drawing/2014/main" id="{388AD67D-6305-4013-8460-7A2555D0E3BA}"/>
               </a:ext>
             </a:extLst>
           </p:cNvPr>
@@ -3475,7 +3475,7 @@
           <p:cNvPr id="4" name="">
             <a:extLst xmlns:a="http://schemas.openxmlformats.org/drawingml/2006/main">
               <a:ext uri="{FF2B5EF4-FFF2-40B4-BE49-F238E27FC236}">
-                <a16:creationId xmlns:a16="http://schemas.microsoft.com/office/drawing/2014/main" id="{47CA6CE2-703D-4028-BF2A-CA89AF54C139}"/>
+                <a16:creationId xmlns:a16="http://schemas.microsoft.com/office/drawing/2014/main" id="{E22F6BE1-6A1F-438A-9693-72151067B055}"/>
               </a:ext>
             </a:extLst>
           </p:cNvPr>
@@ -3530,7 +3530,7 @@
     </p:spTree>
     <p:extLst>
       <p:ext uri="{BB962C8B-B14F-4D97-AF65-F5344CB8AC3E}">
-        <p14:creationId xmlns:p14="http://schemas.microsoft.com/office/powerpoint/2010/main" val="1418562608"/>
+        <p14:creationId xmlns:p14="http://schemas.microsoft.com/office/powerpoint/2010/main" val="514805689"/>
       </p:ext>
     </p:extLst>
   </p:cSld>
@@ -3561,7 +3561,7 @@
           <p:cNvPr id="5" name="">
             <a:extLst xmlns:a="http://schemas.openxmlformats.org/drawingml/2006/main">
               <a:ext uri="{FF2B5EF4-FFF2-40B4-BE49-F238E27FC236}">
-                <a16:creationId xmlns:a16="http://schemas.microsoft.com/office/drawing/2014/main" id="{164BFD1A-9EF8-4112-822C-359AEE0838F1}"/>
+                <a16:creationId xmlns:a16="http://schemas.microsoft.com/office/drawing/2014/main" id="{8E887F8D-ACDF-456B-9719-698EC0E8B96F}"/>
               </a:ext>
             </a:extLst>
           </p:cNvPr>
@@ -3618,7 +3618,7 @@
           <p:cNvPr id="2" name="">
             <a:extLst xmlns:a="http://schemas.openxmlformats.org/drawingml/2006/main">
               <a:ext uri="{FF2B5EF4-FFF2-40B4-BE49-F238E27FC236}">
-                <a16:creationId xmlns:a16="http://schemas.microsoft.com/office/drawing/2014/main" id="{D8971FD0-56F1-40AD-A29E-DCDCA30CDF6E}"/>
+                <a16:creationId xmlns:a16="http://schemas.microsoft.com/office/drawing/2014/main" id="{9AC3D85F-B324-4F57-9EB3-1DEB7B0A3D43}"/>
               </a:ext>
             </a:extLst>
           </p:cNvPr>
@@ -3675,7 +3675,7 @@
           <p:cNvPr id="3" name="">
             <a:extLst xmlns:a="http://schemas.openxmlformats.org/drawingml/2006/main">
               <a:ext uri="{FF2B5EF4-FFF2-40B4-BE49-F238E27FC236}">
-                <a16:creationId xmlns:a16="http://schemas.microsoft.com/office/drawing/2014/main" id="{312A0D3D-933A-4805-A40F-A9DF364F9DAC}"/>
+                <a16:creationId xmlns:a16="http://schemas.microsoft.com/office/drawing/2014/main" id="{92F83979-50A2-4325-A9E8-1C9C4B5281BA}"/>
               </a:ext>
             </a:extLst>
           </p:cNvPr>
@@ -3732,7 +3732,7 @@
           <p:cNvPr id="4" name="">
             <a:extLst xmlns:a="http://schemas.openxmlformats.org/drawingml/2006/main">
               <a:ext uri="{FF2B5EF4-FFF2-40B4-BE49-F238E27FC236}">
-                <a16:creationId xmlns:a16="http://schemas.microsoft.com/office/drawing/2014/main" id="{EFEE141F-B962-454A-973F-FAE23F68BE53}"/>
+                <a16:creationId xmlns:a16="http://schemas.microsoft.com/office/drawing/2014/main" id="{0B9FB3C1-0EF6-42C5-8A06-3C0C41D64D77}"/>
               </a:ext>
             </a:extLst>
           </p:cNvPr>
@@ -3787,7 +3787,7 @@
     </p:spTree>
     <p:extLst>
       <p:ext uri="{BB962C8B-B14F-4D97-AF65-F5344CB8AC3E}">
-        <p14:creationId xmlns:p14="http://schemas.microsoft.com/office/powerpoint/2010/main" val="1839259694"/>
+        <p14:creationId xmlns:p14="http://schemas.microsoft.com/office/powerpoint/2010/main" val="279232385"/>
       </p:ext>
     </p:extLst>
   </p:cSld>
@@ -3818,7 +3818,7 @@
           <p:cNvPr id="5" name="">
             <a:extLst xmlns:a="http://schemas.openxmlformats.org/drawingml/2006/main">
               <a:ext uri="{FF2B5EF4-FFF2-40B4-BE49-F238E27FC236}">
-                <a16:creationId xmlns:a16="http://schemas.microsoft.com/office/drawing/2014/main" id="{B81DB2CD-E7DD-4006-BA1F-85553DB81B7C}"/>
+                <a16:creationId xmlns:a16="http://schemas.microsoft.com/office/drawing/2014/main" id="{E8A06E12-577B-4151-B4B4-578D5AC4BC50}"/>
               </a:ext>
             </a:extLst>
           </p:cNvPr>
@@ -3875,7 +3875,7 @@
           <p:cNvPr id="2" name="">
             <a:extLst xmlns:a="http://schemas.openxmlformats.org/drawingml/2006/main">
               <a:ext uri="{FF2B5EF4-FFF2-40B4-BE49-F238E27FC236}">
-                <a16:creationId xmlns:a16="http://schemas.microsoft.com/office/drawing/2014/main" id="{7E9EC7D4-41B6-471F-9BD4-A65A5F7EDA9B}"/>
+                <a16:creationId xmlns:a16="http://schemas.microsoft.com/office/drawing/2014/main" id="{6977E6BD-F779-4181-9A16-A534D54F1E7D}"/>
               </a:ext>
             </a:extLst>
           </p:cNvPr>
@@ -3932,7 +3932,7 @@
           <p:cNvPr id="3" name="">
             <a:extLst xmlns:a="http://schemas.openxmlformats.org/drawingml/2006/main">
               <a:ext uri="{FF2B5EF4-FFF2-40B4-BE49-F238E27FC236}">
-                <a16:creationId xmlns:a16="http://schemas.microsoft.com/office/drawing/2014/main" id="{C5D70E7F-4527-4E3C-86B3-3CE1A14DCBFF}"/>
+                <a16:creationId xmlns:a16="http://schemas.microsoft.com/office/drawing/2014/main" id="{DFC612B7-6ADC-4411-85D4-8B6EE47FDFA7}"/>
               </a:ext>
             </a:extLst>
           </p:cNvPr>
@@ -3989,7 +3989,7 @@
           <p:cNvPr id="4" name="">
             <a:extLst xmlns:a="http://schemas.openxmlformats.org/drawingml/2006/main">
               <a:ext uri="{FF2B5EF4-FFF2-40B4-BE49-F238E27FC236}">
-                <a16:creationId xmlns:a16="http://schemas.microsoft.com/office/drawing/2014/main" id="{F81738D7-D174-4BDD-9CB4-54F47336F2BD}"/>
+                <a16:creationId xmlns:a16="http://schemas.microsoft.com/office/drawing/2014/main" id="{C43CBE7C-3B1F-45AF-B6E4-33E16A92CF6D}"/>
               </a:ext>
             </a:extLst>
           </p:cNvPr>
@@ -4044,7 +4044,7 @@
     </p:spTree>
     <p:extLst>
       <p:ext uri="{BB962C8B-B14F-4D97-AF65-F5344CB8AC3E}">
-        <p14:creationId xmlns:p14="http://schemas.microsoft.com/office/powerpoint/2010/main" val="561731370"/>
+        <p14:creationId xmlns:p14="http://schemas.microsoft.com/office/powerpoint/2010/main" val="1295678401"/>
       </p:ext>
     </p:extLst>
   </p:cSld>
@@ -4075,7 +4075,7 @@
           <p:cNvPr id="5" name="">
             <a:extLst xmlns:a="http://schemas.openxmlformats.org/drawingml/2006/main">
               <a:ext uri="{FF2B5EF4-FFF2-40B4-BE49-F238E27FC236}">
-                <a16:creationId xmlns:a16="http://schemas.microsoft.com/office/drawing/2014/main" id="{F4343A49-7B12-46A5-B590-467E33D95643}"/>
+                <a16:creationId xmlns:a16="http://schemas.microsoft.com/office/drawing/2014/main" id="{79F0BB81-B323-4C73-91E9-C4ADAC6DD48F}"/>
               </a:ext>
             </a:extLst>
           </p:cNvPr>
@@ -4132,7 +4132,7 @@
           <p:cNvPr id="2" name="">
             <a:extLst xmlns:a="http://schemas.openxmlformats.org/drawingml/2006/main">
               <a:ext uri="{FF2B5EF4-FFF2-40B4-BE49-F238E27FC236}">
-                <a16:creationId xmlns:a16="http://schemas.microsoft.com/office/drawing/2014/main" id="{13AF1E9A-A691-4E96-8D4A-1766AE631594}"/>
+                <a16:creationId xmlns:a16="http://schemas.microsoft.com/office/drawing/2014/main" id="{262C8A62-0250-4141-BF70-2DD439983C71}"/>
               </a:ext>
             </a:extLst>
           </p:cNvPr>
@@ -4656,7 +4656,7 @@
           <p:cNvPr id="4" name="">
             <a:extLst xmlns:a="http://schemas.openxmlformats.org/drawingml/2006/main">
               <a:ext uri="{FF2B5EF4-FFF2-40B4-BE49-F238E27FC236}">
-                <a16:creationId xmlns:a16="http://schemas.microsoft.com/office/drawing/2014/main" id="{ED02E4C3-A043-4331-8732-24ACD2EEE40A}"/>
+                <a16:creationId xmlns:a16="http://schemas.microsoft.com/office/drawing/2014/main" id="{96C30BC3-D848-4E8D-AF96-27455051A000}"/>
               </a:ext>
             </a:extLst>
           </p:cNvPr>
@@ -4711,7 +4711,7 @@
     </p:spTree>
     <p:extLst>
       <p:ext uri="{BB962C8B-B14F-4D97-AF65-F5344CB8AC3E}">
-        <p14:creationId xmlns:p14="http://schemas.microsoft.com/office/powerpoint/2010/main" val="1234169277"/>
+        <p14:creationId xmlns:p14="http://schemas.microsoft.com/office/powerpoint/2010/main" val="1301915842"/>
       </p:ext>
     </p:extLst>
   </p:cSld>
@@ -4742,7 +4742,7 @@
           <p:cNvPr id="6" name="">
             <a:extLst xmlns:a="http://schemas.openxmlformats.org/drawingml/2006/main">
               <a:ext uri="{FF2B5EF4-FFF2-40B4-BE49-F238E27FC236}">
-                <a16:creationId xmlns:a16="http://schemas.microsoft.com/office/drawing/2014/main" id="{B1DE072B-56B9-45BE-85EE-69E2CB97FBE9}"/>
+                <a16:creationId xmlns:a16="http://schemas.microsoft.com/office/drawing/2014/main" id="{BD151420-1CAC-46B2-8685-0FC7705F0A1A}"/>
               </a:ext>
             </a:extLst>
           </p:cNvPr>
@@ -4799,7 +4799,7 @@
           <p:cNvPr id="2" name="">
             <a:extLst xmlns:a="http://schemas.openxmlformats.org/drawingml/2006/main">
               <a:ext uri="{FF2B5EF4-FFF2-40B4-BE49-F238E27FC236}">
-                <a16:creationId xmlns:a16="http://schemas.microsoft.com/office/drawing/2014/main" id="{6F5275D9-E64A-40AC-AF63-70D44D2D2F18}"/>
+                <a16:creationId xmlns:a16="http://schemas.microsoft.com/office/drawing/2014/main" id="{71B7B176-FFC8-4755-8BDE-0453279C8D28}"/>
               </a:ext>
             </a:extLst>
           </p:cNvPr>
@@ -4856,7 +4856,7 @@
           <p:cNvPr id="3" name="">
             <a:extLst xmlns:a="http://schemas.openxmlformats.org/drawingml/2006/main">
               <a:ext uri="{FF2B5EF4-FFF2-40B4-BE49-F238E27FC236}">
-                <a16:creationId xmlns:a16="http://schemas.microsoft.com/office/drawing/2014/main" id="{B964B23C-E87C-4C5A-A797-A7EECDD0190C}"/>
+                <a16:creationId xmlns:a16="http://schemas.microsoft.com/office/drawing/2014/main" id="{510E6D92-9468-45FC-91FE-5960B0A44549}"/>
               </a:ext>
             </a:extLst>
           </p:cNvPr>
@@ -4913,7 +4913,7 @@
           <p:cNvPr id="4" name="">
             <a:extLst xmlns:a="http://schemas.openxmlformats.org/drawingml/2006/main">
               <a:ext uri="{FF2B5EF4-FFF2-40B4-BE49-F238E27FC236}">
-                <a16:creationId xmlns:a16="http://schemas.microsoft.com/office/drawing/2014/main" id="{45440E6F-998C-44FD-975D-2150B5112913}"/>
+                <a16:creationId xmlns:a16="http://schemas.microsoft.com/office/drawing/2014/main" id="{81AE14B7-6CF9-43B4-B2EF-E7C6C815A63E}"/>
               </a:ext>
             </a:extLst>
           </p:cNvPr>
@@ -4970,7 +4970,7 @@
           <p:cNvPr id="5" name="">
             <a:extLst xmlns:a="http://schemas.openxmlformats.org/drawingml/2006/main">
               <a:ext uri="{FF2B5EF4-FFF2-40B4-BE49-F238E27FC236}">
-                <a16:creationId xmlns:a16="http://schemas.microsoft.com/office/drawing/2014/main" id="{19CA92A9-991A-4238-AC4B-D026E6B21F8F}"/>
+                <a16:creationId xmlns:a16="http://schemas.microsoft.com/office/drawing/2014/main" id="{4AFBC845-CFB4-4510-AEA1-E1EB68210BBE}"/>
               </a:ext>
             </a:extLst>
           </p:cNvPr>
@@ -5025,7 +5025,7 @@
     </p:spTree>
     <p:extLst>
       <p:ext uri="{BB962C8B-B14F-4D97-AF65-F5344CB8AC3E}">
-        <p14:creationId xmlns:p14="http://schemas.microsoft.com/office/powerpoint/2010/main" val="1093192275"/>
+        <p14:creationId xmlns:p14="http://schemas.microsoft.com/office/powerpoint/2010/main" val="1917755876"/>
       </p:ext>
     </p:extLst>
   </p:cSld>
@@ -5056,7 +5056,7 @@
           <p:cNvPr id="7" name="">
             <a:extLst xmlns:a="http://schemas.openxmlformats.org/drawingml/2006/main">
               <a:ext uri="{FF2B5EF4-FFF2-40B4-BE49-F238E27FC236}">
-                <a16:creationId xmlns:a16="http://schemas.microsoft.com/office/drawing/2014/main" id="{4124D612-8520-40A2-A844-6F18B8F49070}"/>
+                <a16:creationId xmlns:a16="http://schemas.microsoft.com/office/drawing/2014/main" id="{07B83020-D27E-4CE3-B3AE-2B1DBF95D4C1}"/>
               </a:ext>
             </a:extLst>
           </p:cNvPr>
@@ -5113,7 +5113,7 @@
           <p:cNvPr id="2" name="">
             <a:extLst xmlns:a="http://schemas.openxmlformats.org/drawingml/2006/main">
               <a:ext uri="{FF2B5EF4-FFF2-40B4-BE49-F238E27FC236}">
-                <a16:creationId xmlns:a16="http://schemas.microsoft.com/office/drawing/2014/main" id="{B05246CF-3916-4BE5-A574-AE3E3F8993E6}"/>
+                <a16:creationId xmlns:a16="http://schemas.microsoft.com/office/drawing/2014/main" id="{20636EF9-4128-4F2A-B359-345F244FFFA1}"/>
               </a:ext>
             </a:extLst>
           </p:cNvPr>
@@ -5170,7 +5170,7 @@
           <p:cNvPr id="3" name="">
             <a:extLst xmlns:a="http://schemas.openxmlformats.org/drawingml/2006/main">
               <a:ext uri="{FF2B5EF4-FFF2-40B4-BE49-F238E27FC236}">
-                <a16:creationId xmlns:a16="http://schemas.microsoft.com/office/drawing/2014/main" id="{8ECE35A1-5AC2-439F-92B3-198919C4C117}"/>
+                <a16:creationId xmlns:a16="http://schemas.microsoft.com/office/drawing/2014/main" id="{852D6BF3-60ED-437D-AF0F-596834CF1EC5}"/>
               </a:ext>
             </a:extLst>
           </p:cNvPr>
@@ -5227,7 +5227,7 @@
           <p:cNvPr id="4" name="">
             <a:extLst xmlns:a="http://schemas.openxmlformats.org/drawingml/2006/main">
               <a:ext uri="{FF2B5EF4-FFF2-40B4-BE49-F238E27FC236}">
-                <a16:creationId xmlns:a16="http://schemas.microsoft.com/office/drawing/2014/main" id="{75F25252-BC94-48C3-B1A4-04116160DF5A}"/>
+                <a16:creationId xmlns:a16="http://schemas.microsoft.com/office/drawing/2014/main" id="{E763C762-BBDA-4CEC-973A-1A27A13E10F6}"/>
               </a:ext>
             </a:extLst>
           </p:cNvPr>
@@ -5284,7 +5284,7 @@
           <p:cNvPr id="5" name="">
             <a:extLst xmlns:a="http://schemas.openxmlformats.org/drawingml/2006/main">
               <a:ext uri="{FF2B5EF4-FFF2-40B4-BE49-F238E27FC236}">
-                <a16:creationId xmlns:a16="http://schemas.microsoft.com/office/drawing/2014/main" id="{3A121551-C967-46BC-B824-C10ECDACF891}"/>
+                <a16:creationId xmlns:a16="http://schemas.microsoft.com/office/drawing/2014/main" id="{8FBA5E5D-6711-4118-848D-FA4D202C723F}"/>
               </a:ext>
             </a:extLst>
           </p:cNvPr>
@@ -5341,7 +5341,7 @@
           <p:cNvPr id="6" name="">
             <a:extLst xmlns:a="http://schemas.openxmlformats.org/drawingml/2006/main">
               <a:ext uri="{FF2B5EF4-FFF2-40B4-BE49-F238E27FC236}">
-                <a16:creationId xmlns:a16="http://schemas.microsoft.com/office/drawing/2014/main" id="{47AD9A02-B9A9-4C09-B0E4-CA20B53E0670}"/>
+                <a16:creationId xmlns:a16="http://schemas.microsoft.com/office/drawing/2014/main" id="{3BDB7945-B1B2-49C4-A7B6-5C4C133B3978}"/>
               </a:ext>
             </a:extLst>
           </p:cNvPr>
@@ -5396,7 +5396,7 @@
     </p:spTree>
     <p:extLst>
       <p:ext uri="{BB962C8B-B14F-4D97-AF65-F5344CB8AC3E}">
-        <p14:creationId xmlns:p14="http://schemas.microsoft.com/office/powerpoint/2010/main" val="1324861580"/>
+        <p14:creationId xmlns:p14="http://schemas.microsoft.com/office/powerpoint/2010/main" val="446176074"/>
       </p:ext>
     </p:extLst>
   </p:cSld>
@@ -5427,7 +5427,7 @@
           <p:cNvPr id="4" name="">
             <a:extLst xmlns:a="http://schemas.openxmlformats.org/drawingml/2006/main">
               <a:ext uri="{FF2B5EF4-FFF2-40B4-BE49-F238E27FC236}">
-                <a16:creationId xmlns:a16="http://schemas.microsoft.com/office/drawing/2014/main" id="{4AA64889-F46B-4330-9944-73F64D29A6DE}"/>
+                <a16:creationId xmlns:a16="http://schemas.microsoft.com/office/drawing/2014/main" id="{4AAC07BB-A2CE-4D29-B787-7340EAACD8C3}"/>
               </a:ext>
             </a:extLst>
           </p:cNvPr>
@@ -5951,7 +5951,7 @@
           <p:cNvPr id="3" name="">
             <a:extLst xmlns:a="http://schemas.openxmlformats.org/drawingml/2006/main">
               <a:ext uri="{FF2B5EF4-FFF2-40B4-BE49-F238E27FC236}">
-                <a16:creationId xmlns:a16="http://schemas.microsoft.com/office/drawing/2014/main" id="{F4AB234F-8048-449F-8019-6B7834E3D961}"/>
+                <a16:creationId xmlns:a16="http://schemas.microsoft.com/office/drawing/2014/main" id="{E8FF9497-E8AA-40D5-9A93-FE7A067FD6B3}"/>
               </a:ext>
             </a:extLst>
           </p:cNvPr>
@@ -6006,7 +6006,7 @@
     </p:spTree>
     <p:extLst>
       <p:ext uri="{BB962C8B-B14F-4D97-AF65-F5344CB8AC3E}">
-        <p14:creationId xmlns:p14="http://schemas.microsoft.com/office/powerpoint/2010/main" val="886922101"/>
+        <p14:creationId xmlns:p14="http://schemas.microsoft.com/office/powerpoint/2010/main" val="2002657854"/>
       </p:ext>
     </p:extLst>
   </p:cSld>
@@ -6037,7 +6037,7 @@
           <p:cNvPr id="8" name="">
             <a:extLst xmlns:a="http://schemas.openxmlformats.org/drawingml/2006/main">
               <a:ext uri="{FF2B5EF4-FFF2-40B4-BE49-F238E27FC236}">
-                <a16:creationId xmlns:a16="http://schemas.microsoft.com/office/drawing/2014/main" id="{E3A39114-6169-405E-8FF9-4253E822A1FD}"/>
+                <a16:creationId xmlns:a16="http://schemas.microsoft.com/office/drawing/2014/main" id="{A3F956C1-5363-4DBC-A3DD-4F7815D0F547}"/>
               </a:ext>
             </a:extLst>
           </p:cNvPr>
@@ -6094,7 +6094,7 @@
           <p:cNvPr id="2" name="">
             <a:extLst xmlns:a="http://schemas.openxmlformats.org/drawingml/2006/main">
               <a:ext uri="{FF2B5EF4-FFF2-40B4-BE49-F238E27FC236}">
-                <a16:creationId xmlns:a16="http://schemas.microsoft.com/office/drawing/2014/main" id="{733A5AF7-23E4-45BC-8133-A2F7434DBB6B}"/>
+                <a16:creationId xmlns:a16="http://schemas.microsoft.com/office/drawing/2014/main" id="{3D948195-BF34-4C72-B8B1-58F9A1AD1F0D}"/>
               </a:ext>
             </a:extLst>
           </p:cNvPr>
@@ -6151,7 +6151,7 @@
           <p:cNvPr id="3" name="">
             <a:extLst xmlns:a="http://schemas.openxmlformats.org/drawingml/2006/main">
               <a:ext uri="{FF2B5EF4-FFF2-40B4-BE49-F238E27FC236}">
-                <a16:creationId xmlns:a16="http://schemas.microsoft.com/office/drawing/2014/main" id="{2D4EADB6-AE8C-4FB9-868E-520A5CE4B5C3}"/>
+                <a16:creationId xmlns:a16="http://schemas.microsoft.com/office/drawing/2014/main" id="{58E465D3-0E8E-4035-9E94-F219B2EFB6A7}"/>
               </a:ext>
             </a:extLst>
           </p:cNvPr>
@@ -6208,7 +6208,7 @@
           <p:cNvPr id="4" name="">
             <a:extLst xmlns:a="http://schemas.openxmlformats.org/drawingml/2006/main">
               <a:ext uri="{FF2B5EF4-FFF2-40B4-BE49-F238E27FC236}">
-                <a16:creationId xmlns:a16="http://schemas.microsoft.com/office/drawing/2014/main" id="{9C4AEF4C-B081-492F-97AF-C17B1ED4897B}"/>
+                <a16:creationId xmlns:a16="http://schemas.microsoft.com/office/drawing/2014/main" id="{DB33F778-C8EC-4EA7-B8B6-1102740ECC8A}"/>
               </a:ext>
             </a:extLst>
           </p:cNvPr>
@@ -6265,7 +6265,7 @@
           <p:cNvPr id="5" name="">
             <a:extLst xmlns:a="http://schemas.openxmlformats.org/drawingml/2006/main">
               <a:ext uri="{FF2B5EF4-FFF2-40B4-BE49-F238E27FC236}">
-                <a16:creationId xmlns:a16="http://schemas.microsoft.com/office/drawing/2014/main" id="{0EED233D-E83F-47B5-BECE-9EA94D7D229E}"/>
+                <a16:creationId xmlns:a16="http://schemas.microsoft.com/office/drawing/2014/main" id="{76A41470-6F95-4F09-A7D6-B797C087C55D}"/>
               </a:ext>
             </a:extLst>
           </p:cNvPr>
@@ -6322,7 +6322,7 @@
           <p:cNvPr id="6" name="">
             <a:extLst xmlns:a="http://schemas.openxmlformats.org/drawingml/2006/main">
               <a:ext uri="{FF2B5EF4-FFF2-40B4-BE49-F238E27FC236}">
-                <a16:creationId xmlns:a16="http://schemas.microsoft.com/office/drawing/2014/main" id="{C6FA6AA4-A497-4A4E-9F0A-2D14397F54F7}"/>
+                <a16:creationId xmlns:a16="http://schemas.microsoft.com/office/drawing/2014/main" id="{1813BDD8-5A47-415B-832B-2E1FB7C27C1C}"/>
               </a:ext>
             </a:extLst>
           </p:cNvPr>
@@ -6379,7 +6379,7 @@
           <p:cNvPr id="7" name="">
             <a:extLst xmlns:a="http://schemas.openxmlformats.org/drawingml/2006/main">
               <a:ext uri="{FF2B5EF4-FFF2-40B4-BE49-F238E27FC236}">
-                <a16:creationId xmlns:a16="http://schemas.microsoft.com/office/drawing/2014/main" id="{8D3EC445-FA59-476F-B650-FA5FE334038D}"/>
+                <a16:creationId xmlns:a16="http://schemas.microsoft.com/office/drawing/2014/main" id="{A6612D38-EDEC-476B-AC78-3F69009B54FD}"/>
               </a:ext>
             </a:extLst>
           </p:cNvPr>
@@ -6434,7 +6434,7 @@
     </p:spTree>
     <p:extLst>
       <p:ext uri="{BB962C8B-B14F-4D97-AF65-F5344CB8AC3E}">
-        <p14:creationId xmlns:p14="http://schemas.microsoft.com/office/powerpoint/2010/main" val="1599244362"/>
+        <p14:creationId xmlns:p14="http://schemas.microsoft.com/office/powerpoint/2010/main" val="1394927741"/>
       </p:ext>
     </p:extLst>
   </p:cSld>
@@ -6465,7 +6465,7 @@
           <p:cNvPr id="5" name="">
             <a:extLst xmlns:a="http://schemas.openxmlformats.org/drawingml/2006/main">
               <a:ext uri="{FF2B5EF4-FFF2-40B4-BE49-F238E27FC236}">
-                <a16:creationId xmlns:a16="http://schemas.microsoft.com/office/drawing/2014/main" id="{7D02A8B5-DC0A-4952-AE47-018637B0615B}"/>
+                <a16:creationId xmlns:a16="http://schemas.microsoft.com/office/drawing/2014/main" id="{152432EC-C917-48DB-A9A9-D40B5001C8A5}"/>
               </a:ext>
             </a:extLst>
           </p:cNvPr>
@@ -6522,7 +6522,7 @@
           <p:cNvPr id="2" name="">
             <a:extLst xmlns:a="http://schemas.openxmlformats.org/drawingml/2006/main">
               <a:ext uri="{FF2B5EF4-FFF2-40B4-BE49-F238E27FC236}">
-                <a16:creationId xmlns:a16="http://schemas.microsoft.com/office/drawing/2014/main" id="{3518356A-E920-48F4-85DA-56405BC7C2F1}"/>
+                <a16:creationId xmlns:a16="http://schemas.microsoft.com/office/drawing/2014/main" id="{67043E5F-BD87-4089-96BB-CFED4D93DC65}"/>
               </a:ext>
             </a:extLst>
           </p:cNvPr>
@@ -6579,7 +6579,7 @@
           <p:cNvPr id="3" name="">
             <a:extLst xmlns:a="http://schemas.openxmlformats.org/drawingml/2006/main">
               <a:ext uri="{FF2B5EF4-FFF2-40B4-BE49-F238E27FC236}">
-                <a16:creationId xmlns:a16="http://schemas.microsoft.com/office/drawing/2014/main" id="{D174EF53-C982-4E08-81D8-72107649DE5A}"/>
+                <a16:creationId xmlns:a16="http://schemas.microsoft.com/office/drawing/2014/main" id="{8AD5A934-5091-4AB3-B9B4-121D2F786317}"/>
               </a:ext>
             </a:extLst>
           </p:cNvPr>
@@ -6636,7 +6636,7 @@
           <p:cNvPr id="4" name="">
             <a:extLst xmlns:a="http://schemas.openxmlformats.org/drawingml/2006/main">
               <a:ext uri="{FF2B5EF4-FFF2-40B4-BE49-F238E27FC236}">
-                <a16:creationId xmlns:a16="http://schemas.microsoft.com/office/drawing/2014/main" id="{E0ECDE36-51A3-4D86-A287-8BBF5EC36B83}"/>
+                <a16:creationId xmlns:a16="http://schemas.microsoft.com/office/drawing/2014/main" id="{F4050827-8AEE-4543-A56D-E2388358B2F2}"/>
               </a:ext>
             </a:extLst>
           </p:cNvPr>
@@ -6691,7 +6691,7 @@
     </p:spTree>
     <p:extLst>
       <p:ext uri="{BB962C8B-B14F-4D97-AF65-F5344CB8AC3E}">
-        <p14:creationId xmlns:p14="http://schemas.microsoft.com/office/powerpoint/2010/main" val="2108036139"/>
+        <p14:creationId xmlns:p14="http://schemas.microsoft.com/office/powerpoint/2010/main" val="2109371570"/>
       </p:ext>
     </p:extLst>
   </p:cSld>
@@ -6722,7 +6722,7 @@
           <p:cNvPr id="5" name="">
             <a:extLst xmlns:a="http://schemas.openxmlformats.org/drawingml/2006/main">
               <a:ext uri="{FF2B5EF4-FFF2-40B4-BE49-F238E27FC236}">
-                <a16:creationId xmlns:a16="http://schemas.microsoft.com/office/drawing/2014/main" id="{6FC62DBD-299C-477A-980F-9491872D74FF}"/>
+                <a16:creationId xmlns:a16="http://schemas.microsoft.com/office/drawing/2014/main" id="{6AF1A1BA-960E-41AC-853F-659E31CBAD62}"/>
               </a:ext>
             </a:extLst>
           </p:cNvPr>
@@ -6779,7 +6779,7 @@
           <p:cNvPr id="2" name="">
             <a:extLst xmlns:a="http://schemas.openxmlformats.org/drawingml/2006/main">
               <a:ext uri="{FF2B5EF4-FFF2-40B4-BE49-F238E27FC236}">
-                <a16:creationId xmlns:a16="http://schemas.microsoft.com/office/drawing/2014/main" id="{2BC83718-996E-4328-AD70-680E21C9B967}"/>
+                <a16:creationId xmlns:a16="http://schemas.microsoft.com/office/drawing/2014/main" id="{5D8F92C1-4ACF-46F3-BA9A-E6E05BAA584B}"/>
               </a:ext>
             </a:extLst>
           </p:cNvPr>
@@ -6836,7 +6836,7 @@
           <p:cNvPr id="3" name="">
             <a:extLst xmlns:a="http://schemas.openxmlformats.org/drawingml/2006/main">
               <a:ext uri="{FF2B5EF4-FFF2-40B4-BE49-F238E27FC236}">
-                <a16:creationId xmlns:a16="http://schemas.microsoft.com/office/drawing/2014/main" id="{82327962-2627-44A6-8E4A-F31EF20A192F}"/>
+                <a16:creationId xmlns:a16="http://schemas.microsoft.com/office/drawing/2014/main" id="{2165617C-F0DF-499F-922D-7AB40AE949F0}"/>
               </a:ext>
             </a:extLst>
           </p:cNvPr>
@@ -6893,7 +6893,7 @@
           <p:cNvPr id="4" name="">
             <a:extLst xmlns:a="http://schemas.openxmlformats.org/drawingml/2006/main">
               <a:ext uri="{FF2B5EF4-FFF2-40B4-BE49-F238E27FC236}">
-                <a16:creationId xmlns:a16="http://schemas.microsoft.com/office/drawing/2014/main" id="{03B2CB41-469A-4341-B17E-861D0876639A}"/>
+                <a16:creationId xmlns:a16="http://schemas.microsoft.com/office/drawing/2014/main" id="{8B35955A-5B03-4854-860C-8E857C69CA75}"/>
               </a:ext>
             </a:extLst>
           </p:cNvPr>
@@ -6948,7 +6948,7 @@
     </p:spTree>
     <p:extLst>
       <p:ext uri="{BB962C8B-B14F-4D97-AF65-F5344CB8AC3E}">
-        <p14:creationId xmlns:p14="http://schemas.microsoft.com/office/powerpoint/2010/main" val="607689485"/>
+        <p14:creationId xmlns:p14="http://schemas.microsoft.com/office/powerpoint/2010/main" val="1885137340"/>
       </p:ext>
     </p:extLst>
   </p:cSld>

</xml_diff>